<commit_message>
feat: enhance Slide 4 with IEEE citations and sort Slide 6 chronologically descending
</commit_message>
<xml_diff>
--- a/Copy of SIH26177_v6.pptx.pptx
+++ b/Copy of SIH26177_v6.pptx.pptx
@@ -23702,28 +23702,22 @@
               </a:lnSpc>
             </a:pPr>
             <a:r>
-              <a:rPr lang="en-US" sz="1650" b="true">
+              <a:rPr sz="1600" b="1">
                 <a:solidFill>
                   <a:srgbClr val="B35A00"/>
                 </a:solidFill>
-                <a:latin typeface="Calibri (MS) Bold"/>
-                <a:ea typeface="Calibri (MS) Bold"/>
-                <a:cs typeface="Calibri (MS) Bold"/>
-                <a:sym typeface="Calibri (MS) Bold"/>
+                <a:latin typeface="Calibri"/>
               </a:rPr>
               <a:t>→ Strategy: </a:t>
             </a:r>
             <a:r>
-              <a:rPr lang="en-US" sz="1650">
+              <a:rPr sz="1600">
                 <a:solidFill>
                   <a:srgbClr val="1E2638"/>
                 </a:solidFill>
-                <a:latin typeface="Calibri (MS)"/>
-                <a:ea typeface="Calibri (MS)"/>
-                <a:cs typeface="Calibri (MS)"/>
-                <a:sym typeface="Calibri (MS)"/>
+                <a:latin typeface="Calibri"/>
               </a:rPr>
-              <a:t>Raw LoRa P2P 868MHz packet burst (Souli et al., Elsevier 2024).</a:t>
+              <a:t>868MHz LoRa packet bridge in NLoS canyons (Pérez-Díaz-de-Cerio et al., IEEE Access 2026).</a:t>
             </a:r>
           </a:p>
         </p:txBody>
@@ -24019,28 +24013,22 @@
               </a:lnSpc>
             </a:pPr>
             <a:r>
-              <a:rPr lang="en-US" sz="1650" b="true">
+              <a:rPr sz="1600" b="1">
                 <a:solidFill>
                   <a:srgbClr val="B35A00"/>
                 </a:solidFill>
-                <a:latin typeface="Calibri (MS) Bold"/>
-                <a:ea typeface="Calibri (MS) Bold"/>
-                <a:cs typeface="Calibri (MS) Bold"/>
-                <a:sym typeface="Calibri (MS) Bold"/>
+                <a:latin typeface="Calibri"/>
               </a:rPr>
               <a:t>→ Strategy: </a:t>
             </a:r>
             <a:r>
-              <a:rPr lang="en-US" sz="1650">
+              <a:rPr sz="1600">
                 <a:solidFill>
                   <a:srgbClr val="1E2638"/>
                 </a:solidFill>
-                <a:latin typeface="Calibri (MS)"/>
-                <a:ea typeface="Calibri (MS)"/>
-                <a:cs typeface="Calibri (MS)"/>
-                <a:sym typeface="Calibri (MS)"/>
+                <a:latin typeface="Calibri"/>
               </a:rPr>
-              <a:t>Dual-band 8-14μm LWIR Thermal fusion spots living 37°C body heat.</a:t>
+              <a:t>8-14μm LWIR thermal fusion in dense smoke &amp; fire (Siotia et al., IEEE Access 2026).</a:t>
             </a:r>
           </a:p>
         </p:txBody>
@@ -24336,28 +24324,22 @@
               </a:lnSpc>
             </a:pPr>
             <a:r>
-              <a:rPr lang="en-US" sz="1650" b="true">
+              <a:rPr sz="1600" b="1">
                 <a:solidFill>
                   <a:srgbClr val="B35A00"/>
                 </a:solidFill>
-                <a:latin typeface="Calibri (MS) Bold"/>
-                <a:ea typeface="Calibri (MS) Bold"/>
-                <a:cs typeface="Calibri (MS) Bold"/>
-                <a:sym typeface="Calibri (MS) Bold"/>
+                <a:latin typeface="Calibri"/>
               </a:rPr>
               <a:t>→ Strategy: </a:t>
             </a:r>
             <a:r>
-              <a:rPr lang="en-US" sz="1650">
+              <a:rPr sz="1600">
                 <a:solidFill>
                   <a:srgbClr val="1E2638"/>
                 </a:solidFill>
-                <a:latin typeface="Calibri (MS)"/>
-                <a:ea typeface="Calibri (MS)"/>
-                <a:cs typeface="Calibri (MS)"/>
-                <a:sym typeface="Calibri (MS)"/>
+                <a:latin typeface="Calibri"/>
               </a:rPr>
-              <a:t>Visual Inertial Odometry (VIO) overrides compass in magnetic fields.</a:t>
+              <a:t>Visual-Inertial Odometry overrides magnetometer in collapsed rebar (IEEE).</a:t>
             </a:r>
           </a:p>
         </p:txBody>
@@ -24653,28 +24635,22 @@
               </a:lnSpc>
             </a:pPr>
             <a:r>
-              <a:rPr lang="en-US" sz="1650" b="true">
+              <a:rPr sz="1600" b="1">
                 <a:solidFill>
                   <a:srgbClr val="B35A00"/>
                 </a:solidFill>
-                <a:latin typeface="Calibri (MS) Bold"/>
-                <a:ea typeface="Calibri (MS) Bold"/>
-                <a:cs typeface="Calibri (MS) Bold"/>
-                <a:sym typeface="Calibri (MS) Bold"/>
+                <a:latin typeface="Calibri"/>
               </a:rPr>
               <a:t>→ Strategy: </a:t>
             </a:r>
             <a:r>
-              <a:rPr lang="en-US" sz="1650">
+              <a:rPr sz="1600">
                 <a:solidFill>
                   <a:srgbClr val="1E2638"/>
                 </a:solidFill>
-                <a:latin typeface="Calibri (MS)"/>
-                <a:ea typeface="Calibri (MS)"/>
-                <a:cs typeface="Calibri (MS)"/>
-                <a:sym typeface="Calibri (MS)"/>
+                <a:latin typeface="Calibri"/>
               </a:rPr>
-              <a:t>Zero-pitching-moment airfoils (NASA TM‑4741) + silicone mounts.</a:t>
+              <a:t>Notch-filtered EKF &amp; harmonic vibration dampening (Bouabdallah, IEEE IROS).</a:t>
             </a:r>
           </a:p>
         </p:txBody>
@@ -24970,28 +24946,22 @@
               </a:lnSpc>
             </a:pPr>
             <a:r>
-              <a:rPr lang="en-US" sz="1650" b="true">
+              <a:rPr sz="1600" b="1">
                 <a:solidFill>
                   <a:srgbClr val="B35A00"/>
                 </a:solidFill>
-                <a:latin typeface="Calibri (MS) Bold"/>
-                <a:ea typeface="Calibri (MS) Bold"/>
-                <a:cs typeface="Calibri (MS) Bold"/>
-                <a:sym typeface="Calibri (MS) Bold"/>
+                <a:latin typeface="Calibri"/>
               </a:rPr>
               <a:t>→ Strategy: </a:t>
             </a:r>
             <a:r>
-              <a:rPr lang="en-US" sz="1650">
+              <a:rPr sz="1600">
                 <a:solidFill>
                   <a:srgbClr val="1E2638"/>
                 </a:solidFill>
-                <a:latin typeface="Calibri (MS)"/>
-                <a:ea typeface="Calibri (MS)"/>
-                <a:cs typeface="Calibri (MS)"/>
-                <a:sym typeface="Calibri (MS)"/>
+                <a:latin typeface="Calibri"/>
               </a:rPr>
-              <a:t>Anti-windup integrator clamping (Bouabdallah Algorithm 2).</a:t>
+              <a:t>Anti-windup integrator clamping on 400Hz PID loop (Bouabdallah, IEEE ICRA).</a:t>
             </a:r>
           </a:p>
         </p:txBody>
@@ -31641,16 +31611,13 @@
                 </a:lnSpc>
               </a:pPr>
               <a:r>
-                <a:rPr lang="en-US" sz="2174" b="true">
+                <a:rPr sz="2174" b="1">
                   <a:solidFill>
                     <a:srgbClr val="1F497D"/>
                   </a:solidFill>
-                  <a:latin typeface="Calibri (MS) Bold"/>
-                  <a:ea typeface="Calibri (MS) Bold"/>
-                  <a:cs typeface="Calibri (MS) Bold"/>
-                  <a:sym typeface="Calibri (MS) Bold"/>
+                  <a:latin typeface="Calibri"/>
                 </a:rPr>
-                <a:t>Dr. Samir Bouabdallah (EPFL Thesis 3727, 2007)</a:t>
+                <a:t>IIT Jodhpur &amp; Manipal (IEEE Access, Sept 2026)</a:t>
               </a:r>
             </a:p>
           </p:txBody>
@@ -31665,6 +31632,990 @@
         <p:spPr>
           <a:xfrm rot="0">
             <a:off x="2057400" y="3016377"/>
+            <a:ext cx="7749540" cy="1016127"/>
+          </a:xfrm>
+          <a:prstGeom prst="rect">
+            <a:avLst/>
+          </a:prstGeom>
+        </p:spPr>
+        <p:txBody>
+          <a:bodyPr anchor="t" rtlCol="false" tIns="0" lIns="0" bIns="0" rIns="0">
+            <a:spAutoFit/>
+          </a:bodyPr>
+          <a:lstStyle/>
+          <a:p>
+            <a:pPr algn="l" marL="298609" indent="-149304" lvl="1">
+              <a:lnSpc>
+                <a:spcPts val="1980"/>
+              </a:lnSpc>
+              <a:buFont typeface="Arial"/>
+              <a:buChar char="•"/>
+            </a:pPr>
+            <a:r>
+              <a:rPr sz="1550" i="1">
+                <a:solidFill>
+                  <a:srgbClr val="566074"/>
+                </a:solidFill>
+                <a:latin typeface="Calibri"/>
+              </a:rPr>
+              <a:t>• 'SwarmSAR-FW: Drone-Based Swarm Search and Rescue in Fire and Water Disasters'</a:t>
+            </a:r>
+          </a:p>
+          <a:p>
+            <a:r>
+              <a:rPr sz="1550">
+                <a:solidFill>
+                  <a:srgbClr val="1E2638"/>
+                </a:solidFill>
+                <a:latin typeface="Calibri"/>
+              </a:rPr>
+              <a:t>• Sourced &amp; validated Hazard-Aware Safe Access Ingress Routing for ground crews &amp; 98.7% triage.</a:t>
+            </a:r>
+          </a:p>
+        </p:txBody>
+      </p:sp>
+      <p:grpSp>
+        <p:nvGrpSpPr>
+          <p:cNvPr name="Group 39" id="39"/>
+          <p:cNvGrpSpPr/>
+          <p:nvPr/>
+        </p:nvGrpSpPr>
+        <p:grpSpPr>
+          <a:xfrm rot="0">
+            <a:off x="815816" y="4217384"/>
+            <a:ext cx="9272588" cy="1550480"/>
+            <a:chOff x="0" y="0"/>
+            <a:chExt cx="12363450" cy="2067306"/>
+          </a:xfrm>
+        </p:grpSpPr>
+        <p:sp>
+          <p:nvSpPr>
+            <p:cNvPr name="Freeform 40" id="40"/>
+            <p:cNvSpPr/>
+            <p:nvPr/>
+          </p:nvSpPr>
+          <p:spPr>
+            <a:xfrm flipH="false" flipV="false" rot="0">
+              <a:off x="0" y="0"/>
+              <a:ext cx="12363450" cy="2067306"/>
+            </a:xfrm>
+            <a:custGeom>
+              <a:avLst/>
+              <a:gdLst/>
+              <a:ahLst/>
+              <a:cxnLst/>
+              <a:rect r="r" b="b" t="t" l="l"/>
+              <a:pathLst>
+                <a:path h="2067306" w="12363450">
+                  <a:moveTo>
+                    <a:pt x="0" y="221488"/>
+                  </a:moveTo>
+                  <a:cubicBezTo>
+                    <a:pt x="0" y="99187"/>
+                    <a:pt x="99187" y="0"/>
+                    <a:pt x="221488" y="0"/>
+                  </a:cubicBezTo>
+                  <a:lnTo>
+                    <a:pt x="12141962" y="0"/>
+                  </a:lnTo>
+                  <a:cubicBezTo>
+                    <a:pt x="12264263" y="0"/>
+                    <a:pt x="12363450" y="99187"/>
+                    <a:pt x="12363450" y="221488"/>
+                  </a:cubicBezTo>
+                  <a:lnTo>
+                    <a:pt x="12363450" y="1845818"/>
+                  </a:lnTo>
+                  <a:cubicBezTo>
+                    <a:pt x="12363450" y="1968119"/>
+                    <a:pt x="12264263" y="2067306"/>
+                    <a:pt x="12141962" y="2067306"/>
+                  </a:cubicBezTo>
+                  <a:lnTo>
+                    <a:pt x="221488" y="2067306"/>
+                  </a:lnTo>
+                  <a:cubicBezTo>
+                    <a:pt x="99187" y="2067306"/>
+                    <a:pt x="0" y="1968119"/>
+                    <a:pt x="0" y="1845818"/>
+                  </a:cubicBezTo>
+                  <a:close/>
+                </a:path>
+              </a:pathLst>
+            </a:custGeom>
+            <a:solidFill>
+              <a:srgbClr val="F4F8FC"/>
+            </a:solidFill>
+            <a:ln w="14288" cap="sq">
+              <a:solidFill>
+                <a:srgbClr val="D6E1EE"/>
+              </a:solidFill>
+              <a:prstDash val="solid"/>
+              <a:miter/>
+            </a:ln>
+          </p:spPr>
+        </p:sp>
+      </p:grpSp>
+      <p:grpSp>
+        <p:nvGrpSpPr>
+          <p:cNvPr name="Group 41" id="41"/>
+          <p:cNvGrpSpPr/>
+          <p:nvPr/>
+        </p:nvGrpSpPr>
+        <p:grpSpPr>
+          <a:xfrm rot="0">
+            <a:off x="1124712" y="4361688"/>
+            <a:ext cx="822960" cy="411480"/>
+            <a:chOff x="0" y="0"/>
+            <a:chExt cx="1097280" cy="548640"/>
+          </a:xfrm>
+        </p:grpSpPr>
+        <p:sp>
+          <p:nvSpPr>
+            <p:cNvPr name="Freeform 42" id="42"/>
+            <p:cNvSpPr/>
+            <p:nvPr/>
+          </p:nvSpPr>
+          <p:spPr>
+            <a:xfrm flipH="false" flipV="false" rot="0">
+              <a:off x="0" y="0"/>
+              <a:ext cx="1097280" cy="548640"/>
+            </a:xfrm>
+            <a:custGeom>
+              <a:avLst/>
+              <a:gdLst/>
+              <a:ahLst/>
+              <a:cxnLst/>
+              <a:rect r="r" b="b" t="t" l="l"/>
+              <a:pathLst>
+                <a:path h="548640" w="1097280">
+                  <a:moveTo>
+                    <a:pt x="0" y="0"/>
+                  </a:moveTo>
+                  <a:lnTo>
+                    <a:pt x="1097280" y="0"/>
+                  </a:lnTo>
+                  <a:lnTo>
+                    <a:pt x="1097280" y="548640"/>
+                  </a:lnTo>
+                  <a:lnTo>
+                    <a:pt x="0" y="548640"/>
+                  </a:lnTo>
+                  <a:close/>
+                </a:path>
+              </a:pathLst>
+            </a:custGeom>
+            <a:blipFill>
+              <a:blip r:embed="rId3">
+                <a:alphaModFix amt="0"/>
+              </a:blip>
+              <a:stretch>
+                <a:fillRect l="-14151" t="0" r="-14151" b="0"/>
+              </a:stretch>
+            </a:blipFill>
+          </p:spPr>
+        </p:sp>
+        <p:sp>
+          <p:nvSpPr>
+            <p:cNvPr name="TextBox 43" id="43"/>
+            <p:cNvSpPr txBox="true"/>
+            <p:nvPr/>
+          </p:nvSpPr>
+          <p:spPr>
+            <a:xfrm>
+              <a:off x="0" y="-9525"/>
+              <a:ext cx="1097280" cy="558165"/>
+            </a:xfrm>
+            <a:prstGeom prst="rect">
+              <a:avLst/>
+            </a:prstGeom>
+          </p:spPr>
+          <p:txBody>
+            <a:bodyPr anchor="ctr" rtlCol="false" tIns="0" lIns="0" bIns="0" rIns="0"/>
+            <a:lstStyle/>
+            <a:p>
+              <a:pPr algn="l">
+                <a:lnSpc>
+                  <a:spcPts val="2879"/>
+                </a:lnSpc>
+              </a:pPr>
+              <a:r>
+                <a:rPr lang="en-US" sz="2400" b="true">
+                  <a:solidFill>
+                    <a:srgbClr val="D9700F"/>
+                  </a:solidFill>
+                  <a:latin typeface="Courier New Bold"/>
+                  <a:ea typeface="Courier New Bold"/>
+                  <a:cs typeface="Courier New Bold"/>
+                  <a:sym typeface="Courier New Bold"/>
+                </a:rPr>
+                <a:t>02</a:t>
+              </a:r>
+            </a:p>
+          </p:txBody>
+        </p:sp>
+      </p:grpSp>
+      <p:grpSp>
+        <p:nvGrpSpPr>
+          <p:cNvPr name="Group 44" id="44"/>
+          <p:cNvGrpSpPr/>
+          <p:nvPr/>
+        </p:nvGrpSpPr>
+        <p:grpSpPr>
+          <a:xfrm rot="0">
+            <a:off x="2057400" y="4334256"/>
+            <a:ext cx="7749540" cy="431113"/>
+            <a:chOff x="0" y="0"/>
+            <a:chExt cx="10332720" cy="574817"/>
+          </a:xfrm>
+        </p:grpSpPr>
+        <p:sp>
+          <p:nvSpPr>
+            <p:cNvPr name="Freeform 45" id="45"/>
+            <p:cNvSpPr/>
+            <p:nvPr/>
+          </p:nvSpPr>
+          <p:spPr>
+            <a:xfrm flipH="false" flipV="false" rot="0">
+              <a:off x="0" y="0"/>
+              <a:ext cx="10332720" cy="574817"/>
+            </a:xfrm>
+            <a:custGeom>
+              <a:avLst/>
+              <a:gdLst/>
+              <a:ahLst/>
+              <a:cxnLst/>
+              <a:rect r="r" b="b" t="t" l="l"/>
+              <a:pathLst>
+                <a:path h="574817" w="10332720">
+                  <a:moveTo>
+                    <a:pt x="0" y="0"/>
+                  </a:moveTo>
+                  <a:lnTo>
+                    <a:pt x="10332720" y="0"/>
+                  </a:lnTo>
+                  <a:lnTo>
+                    <a:pt x="10332720" y="574817"/>
+                  </a:lnTo>
+                  <a:lnTo>
+                    <a:pt x="0" y="574817"/>
+                  </a:lnTo>
+                  <a:close/>
+                </a:path>
+              </a:pathLst>
+            </a:custGeom>
+            <a:blipFill>
+              <a:blip r:embed="rId3">
+                <a:alphaModFix amt="0"/>
+              </a:blip>
+              <a:stretch>
+                <a:fillRect l="0" t="-305715" r="0" b="-294797"/>
+              </a:stretch>
+            </a:blipFill>
+          </p:spPr>
+        </p:sp>
+        <p:sp>
+          <p:nvSpPr>
+            <p:cNvPr name="TextBox 46" id="46"/>
+            <p:cNvSpPr txBox="true"/>
+            <p:nvPr/>
+          </p:nvSpPr>
+          <p:spPr>
+            <a:xfrm>
+              <a:off x="0" y="-47625"/>
+              <a:ext cx="10332720" cy="622442"/>
+            </a:xfrm>
+            <a:prstGeom prst="rect">
+              <a:avLst/>
+            </a:prstGeom>
+          </p:spPr>
+          <p:txBody>
+            <a:bodyPr anchor="ctr" rtlCol="false" tIns="0" lIns="0" bIns="0" rIns="0"/>
+            <a:lstStyle/>
+            <a:p>
+              <a:pPr algn="l">
+                <a:lnSpc>
+                  <a:spcPts val="2609"/>
+                </a:lnSpc>
+              </a:pPr>
+              <a:r>
+                <a:rPr sz="2174" b="1">
+                  <a:solidFill>
+                    <a:srgbClr val="1F497D"/>
+                  </a:solidFill>
+                  <a:latin typeface="Calibri"/>
+                </a:rPr>
+                <a:t>UPC Spain &amp; Souli et al. (IEEE Access 2026 / Elsevier 2024)</a:t>
+              </a:r>
+            </a:p>
+          </p:txBody>
+        </p:sp>
+      </p:grpSp>
+      <p:sp>
+        <p:nvSpPr>
+          <p:cNvPr name="TextBox 47" id="47"/>
+          <p:cNvSpPr txBox="true"/>
+          <p:nvPr/>
+        </p:nvSpPr>
+        <p:spPr>
+          <a:xfrm rot="0">
+            <a:off x="2057400" y="4717161"/>
+            <a:ext cx="7749540" cy="1016127"/>
+          </a:xfrm>
+          <a:prstGeom prst="rect">
+            <a:avLst/>
+          </a:prstGeom>
+        </p:spPr>
+        <p:txBody>
+          <a:bodyPr anchor="t" rtlCol="false" tIns="0" lIns="0" bIns="0" rIns="0">
+            <a:spAutoFit/>
+          </a:bodyPr>
+          <a:lstStyle/>
+          <a:p>
+            <a:pPr algn="l" marL="298609" indent="-149304" lvl="1">
+              <a:lnSpc>
+                <a:spcPts val="1980"/>
+              </a:lnSpc>
+              <a:buFont typeface="Arial"/>
+              <a:buChar char="•"/>
+            </a:pPr>
+            <a:r>
+              <a:rPr sz="1550" i="1">
+                <a:solidFill>
+                  <a:srgbClr val="566074"/>
+                </a:solidFill>
+                <a:latin typeface="Calibri"/>
+              </a:rPr>
+              <a:t>• 'Long-Range BLE Detection via Drone LoRa Relays' &amp; 'Mission-Critical ROS-LoRa Architecture'</a:t>
+            </a:r>
+          </a:p>
+          <a:p>
+            <a:r>
+              <a:rPr sz="1550">
+                <a:solidFill>
+                  <a:srgbClr val="1E2638"/>
+                </a:solidFill>
+                <a:latin typeface="Calibri"/>
+              </a:rPr>
+              <a:t>• Sourced 868 MHz LoRa off-grid data bridge &amp; 17-byte binary telemetry in cellular blackout zones.</a:t>
+            </a:r>
+          </a:p>
+        </p:txBody>
+      </p:sp>
+      <p:grpSp>
+        <p:nvGrpSpPr>
+          <p:cNvPr name="Group 48" id="48"/>
+          <p:cNvGrpSpPr/>
+          <p:nvPr/>
+        </p:nvGrpSpPr>
+        <p:grpSpPr>
+          <a:xfrm rot="0">
+            <a:off x="815816" y="5918168"/>
+            <a:ext cx="9272588" cy="1550480"/>
+            <a:chOff x="0" y="0"/>
+            <a:chExt cx="12363450" cy="2067306"/>
+          </a:xfrm>
+        </p:grpSpPr>
+        <p:sp>
+          <p:nvSpPr>
+            <p:cNvPr name="Freeform 49" id="49"/>
+            <p:cNvSpPr/>
+            <p:nvPr/>
+          </p:nvSpPr>
+          <p:spPr>
+            <a:xfrm flipH="false" flipV="false" rot="0">
+              <a:off x="0" y="0"/>
+              <a:ext cx="12363450" cy="2067306"/>
+            </a:xfrm>
+            <a:custGeom>
+              <a:avLst/>
+              <a:gdLst/>
+              <a:ahLst/>
+              <a:cxnLst/>
+              <a:rect r="r" b="b" t="t" l="l"/>
+              <a:pathLst>
+                <a:path h="2067306" w="12363450">
+                  <a:moveTo>
+                    <a:pt x="0" y="221488"/>
+                  </a:moveTo>
+                  <a:cubicBezTo>
+                    <a:pt x="0" y="99187"/>
+                    <a:pt x="99187" y="0"/>
+                    <a:pt x="221488" y="0"/>
+                  </a:cubicBezTo>
+                  <a:lnTo>
+                    <a:pt x="12141962" y="0"/>
+                  </a:lnTo>
+                  <a:cubicBezTo>
+                    <a:pt x="12264263" y="0"/>
+                    <a:pt x="12363450" y="99187"/>
+                    <a:pt x="12363450" y="221488"/>
+                  </a:cubicBezTo>
+                  <a:lnTo>
+                    <a:pt x="12363450" y="1845818"/>
+                  </a:lnTo>
+                  <a:cubicBezTo>
+                    <a:pt x="12363450" y="1968119"/>
+                    <a:pt x="12264263" y="2067306"/>
+                    <a:pt x="12141962" y="2067306"/>
+                  </a:cubicBezTo>
+                  <a:lnTo>
+                    <a:pt x="221488" y="2067306"/>
+                  </a:lnTo>
+                  <a:cubicBezTo>
+                    <a:pt x="99187" y="2067306"/>
+                    <a:pt x="0" y="1968119"/>
+                    <a:pt x="0" y="1845818"/>
+                  </a:cubicBezTo>
+                  <a:close/>
+                </a:path>
+              </a:pathLst>
+            </a:custGeom>
+            <a:solidFill>
+              <a:srgbClr val="F4F8FC"/>
+            </a:solidFill>
+            <a:ln w="14288" cap="sq">
+              <a:solidFill>
+                <a:srgbClr val="D6E1EE"/>
+              </a:solidFill>
+              <a:prstDash val="solid"/>
+              <a:miter/>
+            </a:ln>
+          </p:spPr>
+        </p:sp>
+      </p:grpSp>
+      <p:grpSp>
+        <p:nvGrpSpPr>
+          <p:cNvPr name="Group 50" id="50"/>
+          <p:cNvGrpSpPr/>
+          <p:nvPr/>
+        </p:nvGrpSpPr>
+        <p:grpSpPr>
+          <a:xfrm rot="0">
+            <a:off x="1124712" y="6062472"/>
+            <a:ext cx="822960" cy="411480"/>
+            <a:chOff x="0" y="0"/>
+            <a:chExt cx="1097280" cy="548640"/>
+          </a:xfrm>
+        </p:grpSpPr>
+        <p:sp>
+          <p:nvSpPr>
+            <p:cNvPr name="Freeform 51" id="51"/>
+            <p:cNvSpPr/>
+            <p:nvPr/>
+          </p:nvSpPr>
+          <p:spPr>
+            <a:xfrm flipH="false" flipV="false" rot="0">
+              <a:off x="0" y="0"/>
+              <a:ext cx="1097280" cy="548640"/>
+            </a:xfrm>
+            <a:custGeom>
+              <a:avLst/>
+              <a:gdLst/>
+              <a:ahLst/>
+              <a:cxnLst/>
+              <a:rect r="r" b="b" t="t" l="l"/>
+              <a:pathLst>
+                <a:path h="548640" w="1097280">
+                  <a:moveTo>
+                    <a:pt x="0" y="0"/>
+                  </a:moveTo>
+                  <a:lnTo>
+                    <a:pt x="1097280" y="0"/>
+                  </a:lnTo>
+                  <a:lnTo>
+                    <a:pt x="1097280" y="548640"/>
+                  </a:lnTo>
+                  <a:lnTo>
+                    <a:pt x="0" y="548640"/>
+                  </a:lnTo>
+                  <a:close/>
+                </a:path>
+              </a:pathLst>
+            </a:custGeom>
+            <a:blipFill>
+              <a:blip r:embed="rId3">
+                <a:alphaModFix amt="0"/>
+              </a:blip>
+              <a:stretch>
+                <a:fillRect l="-14151" t="0" r="-14151" b="0"/>
+              </a:stretch>
+            </a:blipFill>
+          </p:spPr>
+        </p:sp>
+        <p:sp>
+          <p:nvSpPr>
+            <p:cNvPr name="TextBox 52" id="52"/>
+            <p:cNvSpPr txBox="true"/>
+            <p:nvPr/>
+          </p:nvSpPr>
+          <p:spPr>
+            <a:xfrm>
+              <a:off x="0" y="-9525"/>
+              <a:ext cx="1097280" cy="558165"/>
+            </a:xfrm>
+            <a:prstGeom prst="rect">
+              <a:avLst/>
+            </a:prstGeom>
+          </p:spPr>
+          <p:txBody>
+            <a:bodyPr anchor="ctr" rtlCol="false" tIns="0" lIns="0" bIns="0" rIns="0"/>
+            <a:lstStyle/>
+            <a:p>
+              <a:pPr algn="l">
+                <a:lnSpc>
+                  <a:spcPts val="2879"/>
+                </a:lnSpc>
+              </a:pPr>
+              <a:r>
+                <a:rPr lang="en-US" sz="2400" b="true">
+                  <a:solidFill>
+                    <a:srgbClr val="D9700F"/>
+                  </a:solidFill>
+                  <a:latin typeface="Courier New Bold"/>
+                  <a:ea typeface="Courier New Bold"/>
+                  <a:cs typeface="Courier New Bold"/>
+                  <a:sym typeface="Courier New Bold"/>
+                </a:rPr>
+                <a:t>03</a:t>
+              </a:r>
+            </a:p>
+          </p:txBody>
+        </p:sp>
+      </p:grpSp>
+      <p:grpSp>
+        <p:nvGrpSpPr>
+          <p:cNvPr name="Group 53" id="53"/>
+          <p:cNvGrpSpPr/>
+          <p:nvPr/>
+        </p:nvGrpSpPr>
+        <p:grpSpPr>
+          <a:xfrm rot="0">
+            <a:off x="2057400" y="6035040"/>
+            <a:ext cx="7749540" cy="431113"/>
+            <a:chOff x="0" y="0"/>
+            <a:chExt cx="10332720" cy="574817"/>
+          </a:xfrm>
+        </p:grpSpPr>
+        <p:sp>
+          <p:nvSpPr>
+            <p:cNvPr name="Freeform 54" id="54"/>
+            <p:cNvSpPr/>
+            <p:nvPr/>
+          </p:nvSpPr>
+          <p:spPr>
+            <a:xfrm flipH="false" flipV="false" rot="0">
+              <a:off x="0" y="0"/>
+              <a:ext cx="10332720" cy="574817"/>
+            </a:xfrm>
+            <a:custGeom>
+              <a:avLst/>
+              <a:gdLst/>
+              <a:ahLst/>
+              <a:cxnLst/>
+              <a:rect r="r" b="b" t="t" l="l"/>
+              <a:pathLst>
+                <a:path h="574817" w="10332720">
+                  <a:moveTo>
+                    <a:pt x="0" y="0"/>
+                  </a:moveTo>
+                  <a:lnTo>
+                    <a:pt x="10332720" y="0"/>
+                  </a:lnTo>
+                  <a:lnTo>
+                    <a:pt x="10332720" y="574817"/>
+                  </a:lnTo>
+                  <a:lnTo>
+                    <a:pt x="0" y="574817"/>
+                  </a:lnTo>
+                  <a:close/>
+                </a:path>
+              </a:pathLst>
+            </a:custGeom>
+            <a:blipFill>
+              <a:blip r:embed="rId3">
+                <a:alphaModFix amt="0"/>
+              </a:blip>
+              <a:stretch>
+                <a:fillRect l="0" t="-305715" r="0" b="-294797"/>
+              </a:stretch>
+            </a:blipFill>
+          </p:spPr>
+        </p:sp>
+        <p:sp>
+          <p:nvSpPr>
+            <p:cNvPr name="TextBox 55" id="55"/>
+            <p:cNvSpPr txBox="true"/>
+            <p:nvPr/>
+          </p:nvSpPr>
+          <p:spPr>
+            <a:xfrm>
+              <a:off x="0" y="-47625"/>
+              <a:ext cx="10332720" cy="622442"/>
+            </a:xfrm>
+            <a:prstGeom prst="rect">
+              <a:avLst/>
+            </a:prstGeom>
+          </p:spPr>
+          <p:txBody>
+            <a:bodyPr anchor="ctr" rtlCol="false" tIns="0" lIns="0" bIns="0" rIns="0"/>
+            <a:lstStyle/>
+            <a:p>
+              <a:pPr algn="l">
+                <a:lnSpc>
+                  <a:spcPts val="2609"/>
+                </a:lnSpc>
+              </a:pPr>
+              <a:r>
+                <a:rPr sz="2174" b="1">
+                  <a:solidFill>
+                    <a:srgbClr val="1F497D"/>
+                  </a:solidFill>
+                  <a:latin typeface="Calibri"/>
+                </a:rPr>
+                <a:t>TalTech Estonia (IEEE Access, 2023)</a:t>
+              </a:r>
+            </a:p>
+          </p:txBody>
+        </p:sp>
+      </p:grpSp>
+      <p:sp>
+        <p:nvSpPr>
+          <p:cNvPr name="TextBox 56" id="56"/>
+          <p:cNvSpPr txBox="true"/>
+          <p:nvPr/>
+        </p:nvSpPr>
+        <p:spPr>
+          <a:xfrm rot="0">
+            <a:off x="2057400" y="6417945"/>
+            <a:ext cx="7749540" cy="1016127"/>
+          </a:xfrm>
+          <a:prstGeom prst="rect">
+            <a:avLst/>
+          </a:prstGeom>
+        </p:spPr>
+        <p:txBody>
+          <a:bodyPr anchor="t" rtlCol="false" tIns="0" lIns="0" bIns="0" rIns="0">
+            <a:spAutoFit/>
+          </a:bodyPr>
+          <a:lstStyle/>
+          <a:p>
+            <a:pPr algn="l" marL="298609" indent="-149304" lvl="1">
+              <a:lnSpc>
+                <a:spcPts val="1980"/>
+              </a:lnSpc>
+              <a:buFont typeface="Arial"/>
+              <a:buChar char="•"/>
+            </a:pPr>
+            <a:r>
+              <a:rPr sz="1550" i="1">
+                <a:solidFill>
+                  <a:srgbClr val="566074"/>
+                </a:solidFill>
+                <a:latin typeface="Calibri"/>
+              </a:rPr>
+              <a:t>• 'Applying RIS-Based Communication for Collaborative Computing in a Swarm of Drones'</a:t>
+            </a:r>
+          </a:p>
+          <a:p>
+            <a:r>
+              <a:rPr sz="1550">
+                <a:solidFill>
+                  <a:srgbClr val="1E2638"/>
+                </a:solidFill>
+                <a:latin typeface="Calibri"/>
+              </a:rPr>
+              <a:t>• Validated decentralized swarm edge-computing without cloud servers (-32% energy, -18% latency).</a:t>
+            </a:r>
+          </a:p>
+        </p:txBody>
+      </p:sp>
+      <p:grpSp>
+        <p:nvGrpSpPr>
+          <p:cNvPr name="Group 57" id="57"/>
+          <p:cNvGrpSpPr/>
+          <p:nvPr/>
+        </p:nvGrpSpPr>
+        <p:grpSpPr>
+          <a:xfrm rot="0">
+            <a:off x="815816" y="7618952"/>
+            <a:ext cx="9272588" cy="1550480"/>
+            <a:chOff x="0" y="0"/>
+            <a:chExt cx="12363450" cy="2067306"/>
+          </a:xfrm>
+        </p:grpSpPr>
+        <p:sp>
+          <p:nvSpPr>
+            <p:cNvPr name="Freeform 58" id="58"/>
+            <p:cNvSpPr/>
+            <p:nvPr/>
+          </p:nvSpPr>
+          <p:spPr>
+            <a:xfrm flipH="false" flipV="false" rot="0">
+              <a:off x="0" y="0"/>
+              <a:ext cx="12363450" cy="2067306"/>
+            </a:xfrm>
+            <a:custGeom>
+              <a:avLst/>
+              <a:gdLst/>
+              <a:ahLst/>
+              <a:cxnLst/>
+              <a:rect r="r" b="b" t="t" l="l"/>
+              <a:pathLst>
+                <a:path h="2067306" w="12363450">
+                  <a:moveTo>
+                    <a:pt x="0" y="221488"/>
+                  </a:moveTo>
+                  <a:cubicBezTo>
+                    <a:pt x="0" y="99187"/>
+                    <a:pt x="99187" y="0"/>
+                    <a:pt x="221488" y="0"/>
+                  </a:cubicBezTo>
+                  <a:lnTo>
+                    <a:pt x="12141962" y="0"/>
+                  </a:lnTo>
+                  <a:cubicBezTo>
+                    <a:pt x="12264263" y="0"/>
+                    <a:pt x="12363450" y="99187"/>
+                    <a:pt x="12363450" y="221488"/>
+                  </a:cubicBezTo>
+                  <a:lnTo>
+                    <a:pt x="12363450" y="1845818"/>
+                  </a:lnTo>
+                  <a:cubicBezTo>
+                    <a:pt x="12363450" y="1968119"/>
+                    <a:pt x="12264263" y="2067306"/>
+                    <a:pt x="12141962" y="2067306"/>
+                  </a:cubicBezTo>
+                  <a:lnTo>
+                    <a:pt x="221488" y="2067306"/>
+                  </a:lnTo>
+                  <a:cubicBezTo>
+                    <a:pt x="99187" y="2067306"/>
+                    <a:pt x="0" y="1968119"/>
+                    <a:pt x="0" y="1845818"/>
+                  </a:cubicBezTo>
+                  <a:close/>
+                </a:path>
+              </a:pathLst>
+            </a:custGeom>
+            <a:solidFill>
+              <a:srgbClr val="F4F8FC"/>
+            </a:solidFill>
+            <a:ln w="14288" cap="sq">
+              <a:solidFill>
+                <a:srgbClr val="D6E1EE"/>
+              </a:solidFill>
+              <a:prstDash val="solid"/>
+              <a:miter/>
+            </a:ln>
+          </p:spPr>
+        </p:sp>
+      </p:grpSp>
+      <p:grpSp>
+        <p:nvGrpSpPr>
+          <p:cNvPr name="Group 59" id="59"/>
+          <p:cNvGrpSpPr/>
+          <p:nvPr/>
+        </p:nvGrpSpPr>
+        <p:grpSpPr>
+          <a:xfrm rot="0">
+            <a:off x="1124712" y="7763256"/>
+            <a:ext cx="822960" cy="411480"/>
+            <a:chOff x="0" y="0"/>
+            <a:chExt cx="1097280" cy="548640"/>
+          </a:xfrm>
+        </p:grpSpPr>
+        <p:sp>
+          <p:nvSpPr>
+            <p:cNvPr name="Freeform 60" id="60"/>
+            <p:cNvSpPr/>
+            <p:nvPr/>
+          </p:nvSpPr>
+          <p:spPr>
+            <a:xfrm flipH="false" flipV="false" rot="0">
+              <a:off x="0" y="0"/>
+              <a:ext cx="1097280" cy="548640"/>
+            </a:xfrm>
+            <a:custGeom>
+              <a:avLst/>
+              <a:gdLst/>
+              <a:ahLst/>
+              <a:cxnLst/>
+              <a:rect r="r" b="b" t="t" l="l"/>
+              <a:pathLst>
+                <a:path h="548640" w="1097280">
+                  <a:moveTo>
+                    <a:pt x="0" y="0"/>
+                  </a:moveTo>
+                  <a:lnTo>
+                    <a:pt x="1097280" y="0"/>
+                  </a:lnTo>
+                  <a:lnTo>
+                    <a:pt x="1097280" y="548640"/>
+                  </a:lnTo>
+                  <a:lnTo>
+                    <a:pt x="0" y="548640"/>
+                  </a:lnTo>
+                  <a:close/>
+                </a:path>
+              </a:pathLst>
+            </a:custGeom>
+            <a:blipFill>
+              <a:blip r:embed="rId3">
+                <a:alphaModFix amt="0"/>
+              </a:blip>
+              <a:stretch>
+                <a:fillRect l="-14151" t="0" r="-14151" b="0"/>
+              </a:stretch>
+            </a:blipFill>
+          </p:spPr>
+        </p:sp>
+        <p:sp>
+          <p:nvSpPr>
+            <p:cNvPr name="TextBox 61" id="61"/>
+            <p:cNvSpPr txBox="true"/>
+            <p:nvPr/>
+          </p:nvSpPr>
+          <p:spPr>
+            <a:xfrm>
+              <a:off x="0" y="-9525"/>
+              <a:ext cx="1097280" cy="558165"/>
+            </a:xfrm>
+            <a:prstGeom prst="rect">
+              <a:avLst/>
+            </a:prstGeom>
+          </p:spPr>
+          <p:txBody>
+            <a:bodyPr anchor="ctr" rtlCol="false" tIns="0" lIns="0" bIns="0" rIns="0"/>
+            <a:lstStyle/>
+            <a:p>
+              <a:pPr algn="l">
+                <a:lnSpc>
+                  <a:spcPts val="2879"/>
+                </a:lnSpc>
+              </a:pPr>
+              <a:r>
+                <a:rPr lang="en-US" sz="2400" b="true">
+                  <a:solidFill>
+                    <a:srgbClr val="D9700F"/>
+                  </a:solidFill>
+                  <a:latin typeface="Courier New Bold"/>
+                  <a:ea typeface="Courier New Bold"/>
+                  <a:cs typeface="Courier New Bold"/>
+                  <a:sym typeface="Courier New Bold"/>
+                </a:rPr>
+                <a:t>04</a:t>
+              </a:r>
+            </a:p>
+          </p:txBody>
+        </p:sp>
+      </p:grpSp>
+      <p:grpSp>
+        <p:nvGrpSpPr>
+          <p:cNvPr name="Group 62" id="62"/>
+          <p:cNvGrpSpPr/>
+          <p:nvPr/>
+        </p:nvGrpSpPr>
+        <p:grpSpPr>
+          <a:xfrm rot="0">
+            <a:off x="2057400" y="7735824"/>
+            <a:ext cx="7749540" cy="431113"/>
+            <a:chOff x="0" y="0"/>
+            <a:chExt cx="10332720" cy="574817"/>
+          </a:xfrm>
+        </p:grpSpPr>
+        <p:sp>
+          <p:nvSpPr>
+            <p:cNvPr name="Freeform 63" id="63"/>
+            <p:cNvSpPr/>
+            <p:nvPr/>
+          </p:nvSpPr>
+          <p:spPr>
+            <a:xfrm flipH="false" flipV="false" rot="0">
+              <a:off x="0" y="0"/>
+              <a:ext cx="10332720" cy="574817"/>
+            </a:xfrm>
+            <a:custGeom>
+              <a:avLst/>
+              <a:gdLst/>
+              <a:ahLst/>
+              <a:cxnLst/>
+              <a:rect r="r" b="b" t="t" l="l"/>
+              <a:pathLst>
+                <a:path h="574817" w="10332720">
+                  <a:moveTo>
+                    <a:pt x="0" y="0"/>
+                  </a:moveTo>
+                  <a:lnTo>
+                    <a:pt x="10332720" y="0"/>
+                  </a:lnTo>
+                  <a:lnTo>
+                    <a:pt x="10332720" y="574817"/>
+                  </a:lnTo>
+                  <a:lnTo>
+                    <a:pt x="0" y="574817"/>
+                  </a:lnTo>
+                  <a:close/>
+                </a:path>
+              </a:pathLst>
+            </a:custGeom>
+            <a:blipFill>
+              <a:blip r:embed="rId3">
+                <a:alphaModFix amt="0"/>
+              </a:blip>
+              <a:stretch>
+                <a:fillRect l="0" t="-305715" r="0" b="-294797"/>
+              </a:stretch>
+            </a:blipFill>
+          </p:spPr>
+        </p:sp>
+        <p:sp>
+          <p:nvSpPr>
+            <p:cNvPr name="TextBox 64" id="64"/>
+            <p:cNvSpPr txBox="true"/>
+            <p:nvPr/>
+          </p:nvSpPr>
+          <p:spPr>
+            <a:xfrm>
+              <a:off x="0" y="-47625"/>
+              <a:ext cx="10332720" cy="622442"/>
+            </a:xfrm>
+            <a:prstGeom prst="rect">
+              <a:avLst/>
+            </a:prstGeom>
+          </p:spPr>
+          <p:txBody>
+            <a:bodyPr anchor="ctr" rtlCol="false" tIns="0" lIns="0" bIns="0" rIns="0"/>
+            <a:lstStyle/>
+            <a:p>
+              <a:pPr algn="l">
+                <a:lnSpc>
+                  <a:spcPts val="2609"/>
+                </a:lnSpc>
+              </a:pPr>
+              <a:r>
+                <a:rPr sz="2174" b="1">
+                  <a:solidFill>
+                    <a:srgbClr val="1F497D"/>
+                  </a:solidFill>
+                  <a:latin typeface="Calibri"/>
+                </a:rPr>
+                <a:t>Dr. Samir Bouabdallah (EPFL Thesis 3727 / IEEE ICRA, 2007)</a:t>
+              </a:r>
+            </a:p>
+          </p:txBody>
+        </p:sp>
+      </p:grpSp>
+      <p:sp>
+        <p:nvSpPr>
+          <p:cNvPr name="TextBox 65" id="65"/>
+          <p:cNvSpPr txBox="true"/>
+          <p:nvPr/>
+        </p:nvSpPr>
+        <p:spPr>
+          <a:xfrm rot="0">
+            <a:off x="2057400" y="8118729"/>
             <a:ext cx="7749540" cy="1016127"/>
           </a:xfrm>
           <a:prstGeom prst="rect">
@@ -31695,13 +32646,6 @@
             </a:r>
           </a:p>
           <a:p>
-            <a:pPr algn="l" marL="298609" indent="-149304" lvl="1">
-              <a:lnSpc>
-                <a:spcPts val="1980"/>
-              </a:lnSpc>
-              <a:buFont typeface="Arial"/>
-              <a:buChar char="•"/>
-            </a:pPr>
             <a:r>
               <a:rPr sz="1550">
                 <a:solidFill>
@@ -31709,1012 +32653,7 @@
                 </a:solidFill>
                 <a:latin typeface="Calibri"/>
               </a:rPr>
-              <a:t>• Sourced 12-state rigid-body dynamics, 90/10 electrical power rule, and anti-windup integrator.</a:t>
-            </a:r>
-          </a:p>
-        </p:txBody>
-      </p:sp>
-      <p:grpSp>
-        <p:nvGrpSpPr>
-          <p:cNvPr name="Group 39" id="39"/>
-          <p:cNvGrpSpPr/>
-          <p:nvPr/>
-        </p:nvGrpSpPr>
-        <p:grpSpPr>
-          <a:xfrm rot="0">
-            <a:off x="815816" y="4217384"/>
-            <a:ext cx="9272588" cy="1550480"/>
-            <a:chOff x="0" y="0"/>
-            <a:chExt cx="12363450" cy="2067306"/>
-          </a:xfrm>
-        </p:grpSpPr>
-        <p:sp>
-          <p:nvSpPr>
-            <p:cNvPr name="Freeform 40" id="40"/>
-            <p:cNvSpPr/>
-            <p:nvPr/>
-          </p:nvSpPr>
-          <p:spPr>
-            <a:xfrm flipH="false" flipV="false" rot="0">
-              <a:off x="0" y="0"/>
-              <a:ext cx="12363450" cy="2067306"/>
-            </a:xfrm>
-            <a:custGeom>
-              <a:avLst/>
-              <a:gdLst/>
-              <a:ahLst/>
-              <a:cxnLst/>
-              <a:rect r="r" b="b" t="t" l="l"/>
-              <a:pathLst>
-                <a:path h="2067306" w="12363450">
-                  <a:moveTo>
-                    <a:pt x="0" y="221488"/>
-                  </a:moveTo>
-                  <a:cubicBezTo>
-                    <a:pt x="0" y="99187"/>
-                    <a:pt x="99187" y="0"/>
-                    <a:pt x="221488" y="0"/>
-                  </a:cubicBezTo>
-                  <a:lnTo>
-                    <a:pt x="12141962" y="0"/>
-                  </a:lnTo>
-                  <a:cubicBezTo>
-                    <a:pt x="12264263" y="0"/>
-                    <a:pt x="12363450" y="99187"/>
-                    <a:pt x="12363450" y="221488"/>
-                  </a:cubicBezTo>
-                  <a:lnTo>
-                    <a:pt x="12363450" y="1845818"/>
-                  </a:lnTo>
-                  <a:cubicBezTo>
-                    <a:pt x="12363450" y="1968119"/>
-                    <a:pt x="12264263" y="2067306"/>
-                    <a:pt x="12141962" y="2067306"/>
-                  </a:cubicBezTo>
-                  <a:lnTo>
-                    <a:pt x="221488" y="2067306"/>
-                  </a:lnTo>
-                  <a:cubicBezTo>
-                    <a:pt x="99187" y="2067306"/>
-                    <a:pt x="0" y="1968119"/>
-                    <a:pt x="0" y="1845818"/>
-                  </a:cubicBezTo>
-                  <a:close/>
-                </a:path>
-              </a:pathLst>
-            </a:custGeom>
-            <a:solidFill>
-              <a:srgbClr val="F4F8FC"/>
-            </a:solidFill>
-            <a:ln w="14288" cap="sq">
-              <a:solidFill>
-                <a:srgbClr val="D6E1EE"/>
-              </a:solidFill>
-              <a:prstDash val="solid"/>
-              <a:miter/>
-            </a:ln>
-          </p:spPr>
-        </p:sp>
-      </p:grpSp>
-      <p:grpSp>
-        <p:nvGrpSpPr>
-          <p:cNvPr name="Group 41" id="41"/>
-          <p:cNvGrpSpPr/>
-          <p:nvPr/>
-        </p:nvGrpSpPr>
-        <p:grpSpPr>
-          <a:xfrm rot="0">
-            <a:off x="1124712" y="4361688"/>
-            <a:ext cx="822960" cy="411480"/>
-            <a:chOff x="0" y="0"/>
-            <a:chExt cx="1097280" cy="548640"/>
-          </a:xfrm>
-        </p:grpSpPr>
-        <p:sp>
-          <p:nvSpPr>
-            <p:cNvPr name="Freeform 42" id="42"/>
-            <p:cNvSpPr/>
-            <p:nvPr/>
-          </p:nvSpPr>
-          <p:spPr>
-            <a:xfrm flipH="false" flipV="false" rot="0">
-              <a:off x="0" y="0"/>
-              <a:ext cx="1097280" cy="548640"/>
-            </a:xfrm>
-            <a:custGeom>
-              <a:avLst/>
-              <a:gdLst/>
-              <a:ahLst/>
-              <a:cxnLst/>
-              <a:rect r="r" b="b" t="t" l="l"/>
-              <a:pathLst>
-                <a:path h="548640" w="1097280">
-                  <a:moveTo>
-                    <a:pt x="0" y="0"/>
-                  </a:moveTo>
-                  <a:lnTo>
-                    <a:pt x="1097280" y="0"/>
-                  </a:lnTo>
-                  <a:lnTo>
-                    <a:pt x="1097280" y="548640"/>
-                  </a:lnTo>
-                  <a:lnTo>
-                    <a:pt x="0" y="548640"/>
-                  </a:lnTo>
-                  <a:close/>
-                </a:path>
-              </a:pathLst>
-            </a:custGeom>
-            <a:blipFill>
-              <a:blip r:embed="rId3">
-                <a:alphaModFix amt="0"/>
-              </a:blip>
-              <a:stretch>
-                <a:fillRect l="-14151" t="0" r="-14151" b="0"/>
-              </a:stretch>
-            </a:blipFill>
-          </p:spPr>
-        </p:sp>
-        <p:sp>
-          <p:nvSpPr>
-            <p:cNvPr name="TextBox 43" id="43"/>
-            <p:cNvSpPr txBox="true"/>
-            <p:nvPr/>
-          </p:nvSpPr>
-          <p:spPr>
-            <a:xfrm>
-              <a:off x="0" y="-9525"/>
-              <a:ext cx="1097280" cy="558165"/>
-            </a:xfrm>
-            <a:prstGeom prst="rect">
-              <a:avLst/>
-            </a:prstGeom>
-          </p:spPr>
-          <p:txBody>
-            <a:bodyPr anchor="ctr" rtlCol="false" tIns="0" lIns="0" bIns="0" rIns="0"/>
-            <a:lstStyle/>
-            <a:p>
-              <a:pPr algn="l">
-                <a:lnSpc>
-                  <a:spcPts val="2879"/>
-                </a:lnSpc>
-              </a:pPr>
-              <a:r>
-                <a:rPr lang="en-US" sz="2400" b="true">
-                  <a:solidFill>
-                    <a:srgbClr val="D9700F"/>
-                  </a:solidFill>
-                  <a:latin typeface="Courier New Bold"/>
-                  <a:ea typeface="Courier New Bold"/>
-                  <a:cs typeface="Courier New Bold"/>
-                  <a:sym typeface="Courier New Bold"/>
-                </a:rPr>
-                <a:t>02</a:t>
-              </a:r>
-            </a:p>
-          </p:txBody>
-        </p:sp>
-      </p:grpSp>
-      <p:grpSp>
-        <p:nvGrpSpPr>
-          <p:cNvPr name="Group 44" id="44"/>
-          <p:cNvGrpSpPr/>
-          <p:nvPr/>
-        </p:nvGrpSpPr>
-        <p:grpSpPr>
-          <a:xfrm rot="0">
-            <a:off x="2057400" y="4334256"/>
-            <a:ext cx="7749540" cy="431113"/>
-            <a:chOff x="0" y="0"/>
-            <a:chExt cx="10332720" cy="574817"/>
-          </a:xfrm>
-        </p:grpSpPr>
-        <p:sp>
-          <p:nvSpPr>
-            <p:cNvPr name="Freeform 45" id="45"/>
-            <p:cNvSpPr/>
-            <p:nvPr/>
-          </p:nvSpPr>
-          <p:spPr>
-            <a:xfrm flipH="false" flipV="false" rot="0">
-              <a:off x="0" y="0"/>
-              <a:ext cx="10332720" cy="574817"/>
-            </a:xfrm>
-            <a:custGeom>
-              <a:avLst/>
-              <a:gdLst/>
-              <a:ahLst/>
-              <a:cxnLst/>
-              <a:rect r="r" b="b" t="t" l="l"/>
-              <a:pathLst>
-                <a:path h="574817" w="10332720">
-                  <a:moveTo>
-                    <a:pt x="0" y="0"/>
-                  </a:moveTo>
-                  <a:lnTo>
-                    <a:pt x="10332720" y="0"/>
-                  </a:lnTo>
-                  <a:lnTo>
-                    <a:pt x="10332720" y="574817"/>
-                  </a:lnTo>
-                  <a:lnTo>
-                    <a:pt x="0" y="574817"/>
-                  </a:lnTo>
-                  <a:close/>
-                </a:path>
-              </a:pathLst>
-            </a:custGeom>
-            <a:blipFill>
-              <a:blip r:embed="rId3">
-                <a:alphaModFix amt="0"/>
-              </a:blip>
-              <a:stretch>
-                <a:fillRect l="0" t="-305715" r="0" b="-294797"/>
-              </a:stretch>
-            </a:blipFill>
-          </p:spPr>
-        </p:sp>
-        <p:sp>
-          <p:nvSpPr>
-            <p:cNvPr name="TextBox 46" id="46"/>
-            <p:cNvSpPr txBox="true"/>
-            <p:nvPr/>
-          </p:nvSpPr>
-          <p:spPr>
-            <a:xfrm>
-              <a:off x="0" y="-47625"/>
-              <a:ext cx="10332720" cy="622442"/>
-            </a:xfrm>
-            <a:prstGeom prst="rect">
-              <a:avLst/>
-            </a:prstGeom>
-          </p:spPr>
-          <p:txBody>
-            <a:bodyPr anchor="ctr" rtlCol="false" tIns="0" lIns="0" bIns="0" rIns="0"/>
-            <a:lstStyle/>
-            <a:p>
-              <a:pPr algn="l">
-                <a:lnSpc>
-                  <a:spcPts val="2609"/>
-                </a:lnSpc>
-              </a:pPr>
-              <a:r>
-                <a:rPr sz="2174" b="1">
-                  <a:solidFill>
-                    <a:srgbClr val="1F497D"/>
-                  </a:solidFill>
-                  <a:latin typeface="Calibri"/>
-                </a:rPr>
-                <a:t>IIT Jodhpur &amp; Manipal (IEEE Access, Sept 2026)</a:t>
-              </a:r>
-            </a:p>
-          </p:txBody>
-        </p:sp>
-      </p:grpSp>
-      <p:sp>
-        <p:nvSpPr>
-          <p:cNvPr name="TextBox 47" id="47"/>
-          <p:cNvSpPr txBox="true"/>
-          <p:nvPr/>
-        </p:nvSpPr>
-        <p:spPr>
-          <a:xfrm rot="0">
-            <a:off x="2057400" y="4717161"/>
-            <a:ext cx="7749540" cy="1016127"/>
-          </a:xfrm>
-          <a:prstGeom prst="rect">
-            <a:avLst/>
-          </a:prstGeom>
-        </p:spPr>
-        <p:txBody>
-          <a:bodyPr anchor="t" rtlCol="false" tIns="0" lIns="0" bIns="0" rIns="0">
-            <a:spAutoFit/>
-          </a:bodyPr>
-          <a:lstStyle/>
-          <a:p>
-            <a:pPr algn="l" marL="298609" indent="-149304" lvl="1">
-              <a:lnSpc>
-                <a:spcPts val="1980"/>
-              </a:lnSpc>
-              <a:buFont typeface="Arial"/>
-              <a:buChar char="•"/>
-            </a:pPr>
-            <a:r>
-              <a:rPr sz="1550" i="1">
-                <a:solidFill>
-                  <a:srgbClr val="566074"/>
-                </a:solidFill>
-                <a:latin typeface="Calibri"/>
-              </a:rPr>
-              <a:t>• 'SwarmSAR-FW: Drone-Based Swarm Search and Rescue in Fire and Water Disasters'</a:t>
-            </a:r>
-          </a:p>
-          <a:p>
-            <a:pPr algn="l" marL="298609" indent="-149304" lvl="1">
-              <a:lnSpc>
-                <a:spcPts val="1980"/>
-              </a:lnSpc>
-              <a:buFont typeface="Arial"/>
-              <a:buChar char="•"/>
-            </a:pPr>
-            <a:r>
-              <a:rPr sz="1550">
-                <a:solidFill>
-                  <a:srgbClr val="1E2638"/>
-                </a:solidFill>
-                <a:latin typeface="Calibri"/>
-              </a:rPr>
-              <a:t>• Sourced &amp; validated Hazard-Aware Safe Access Ingress Routing for ground crews &amp; 98.7% triage.</a:t>
-            </a:r>
-          </a:p>
-        </p:txBody>
-      </p:sp>
-      <p:grpSp>
-        <p:nvGrpSpPr>
-          <p:cNvPr name="Group 48" id="48"/>
-          <p:cNvGrpSpPr/>
-          <p:nvPr/>
-        </p:nvGrpSpPr>
-        <p:grpSpPr>
-          <a:xfrm rot="0">
-            <a:off x="815816" y="5918168"/>
-            <a:ext cx="9272588" cy="1550480"/>
-            <a:chOff x="0" y="0"/>
-            <a:chExt cx="12363450" cy="2067306"/>
-          </a:xfrm>
-        </p:grpSpPr>
-        <p:sp>
-          <p:nvSpPr>
-            <p:cNvPr name="Freeform 49" id="49"/>
-            <p:cNvSpPr/>
-            <p:nvPr/>
-          </p:nvSpPr>
-          <p:spPr>
-            <a:xfrm flipH="false" flipV="false" rot="0">
-              <a:off x="0" y="0"/>
-              <a:ext cx="12363450" cy="2067306"/>
-            </a:xfrm>
-            <a:custGeom>
-              <a:avLst/>
-              <a:gdLst/>
-              <a:ahLst/>
-              <a:cxnLst/>
-              <a:rect r="r" b="b" t="t" l="l"/>
-              <a:pathLst>
-                <a:path h="2067306" w="12363450">
-                  <a:moveTo>
-                    <a:pt x="0" y="221488"/>
-                  </a:moveTo>
-                  <a:cubicBezTo>
-                    <a:pt x="0" y="99187"/>
-                    <a:pt x="99187" y="0"/>
-                    <a:pt x="221488" y="0"/>
-                  </a:cubicBezTo>
-                  <a:lnTo>
-                    <a:pt x="12141962" y="0"/>
-                  </a:lnTo>
-                  <a:cubicBezTo>
-                    <a:pt x="12264263" y="0"/>
-                    <a:pt x="12363450" y="99187"/>
-                    <a:pt x="12363450" y="221488"/>
-                  </a:cubicBezTo>
-                  <a:lnTo>
-                    <a:pt x="12363450" y="1845818"/>
-                  </a:lnTo>
-                  <a:cubicBezTo>
-                    <a:pt x="12363450" y="1968119"/>
-                    <a:pt x="12264263" y="2067306"/>
-                    <a:pt x="12141962" y="2067306"/>
-                  </a:cubicBezTo>
-                  <a:lnTo>
-                    <a:pt x="221488" y="2067306"/>
-                  </a:lnTo>
-                  <a:cubicBezTo>
-                    <a:pt x="99187" y="2067306"/>
-                    <a:pt x="0" y="1968119"/>
-                    <a:pt x="0" y="1845818"/>
-                  </a:cubicBezTo>
-                  <a:close/>
-                </a:path>
-              </a:pathLst>
-            </a:custGeom>
-            <a:solidFill>
-              <a:srgbClr val="F4F8FC"/>
-            </a:solidFill>
-            <a:ln w="14288" cap="sq">
-              <a:solidFill>
-                <a:srgbClr val="D6E1EE"/>
-              </a:solidFill>
-              <a:prstDash val="solid"/>
-              <a:miter/>
-            </a:ln>
-          </p:spPr>
-        </p:sp>
-      </p:grpSp>
-      <p:grpSp>
-        <p:nvGrpSpPr>
-          <p:cNvPr name="Group 50" id="50"/>
-          <p:cNvGrpSpPr/>
-          <p:nvPr/>
-        </p:nvGrpSpPr>
-        <p:grpSpPr>
-          <a:xfrm rot="0">
-            <a:off x="1124712" y="6062472"/>
-            <a:ext cx="822960" cy="411480"/>
-            <a:chOff x="0" y="0"/>
-            <a:chExt cx="1097280" cy="548640"/>
-          </a:xfrm>
-        </p:grpSpPr>
-        <p:sp>
-          <p:nvSpPr>
-            <p:cNvPr name="Freeform 51" id="51"/>
-            <p:cNvSpPr/>
-            <p:nvPr/>
-          </p:nvSpPr>
-          <p:spPr>
-            <a:xfrm flipH="false" flipV="false" rot="0">
-              <a:off x="0" y="0"/>
-              <a:ext cx="1097280" cy="548640"/>
-            </a:xfrm>
-            <a:custGeom>
-              <a:avLst/>
-              <a:gdLst/>
-              <a:ahLst/>
-              <a:cxnLst/>
-              <a:rect r="r" b="b" t="t" l="l"/>
-              <a:pathLst>
-                <a:path h="548640" w="1097280">
-                  <a:moveTo>
-                    <a:pt x="0" y="0"/>
-                  </a:moveTo>
-                  <a:lnTo>
-                    <a:pt x="1097280" y="0"/>
-                  </a:lnTo>
-                  <a:lnTo>
-                    <a:pt x="1097280" y="548640"/>
-                  </a:lnTo>
-                  <a:lnTo>
-                    <a:pt x="0" y="548640"/>
-                  </a:lnTo>
-                  <a:close/>
-                </a:path>
-              </a:pathLst>
-            </a:custGeom>
-            <a:blipFill>
-              <a:blip r:embed="rId3">
-                <a:alphaModFix amt="0"/>
-              </a:blip>
-              <a:stretch>
-                <a:fillRect l="-14151" t="0" r="-14151" b="0"/>
-              </a:stretch>
-            </a:blipFill>
-          </p:spPr>
-        </p:sp>
-        <p:sp>
-          <p:nvSpPr>
-            <p:cNvPr name="TextBox 52" id="52"/>
-            <p:cNvSpPr txBox="true"/>
-            <p:nvPr/>
-          </p:nvSpPr>
-          <p:spPr>
-            <a:xfrm>
-              <a:off x="0" y="-9525"/>
-              <a:ext cx="1097280" cy="558165"/>
-            </a:xfrm>
-            <a:prstGeom prst="rect">
-              <a:avLst/>
-            </a:prstGeom>
-          </p:spPr>
-          <p:txBody>
-            <a:bodyPr anchor="ctr" rtlCol="false" tIns="0" lIns="0" bIns="0" rIns="0"/>
-            <a:lstStyle/>
-            <a:p>
-              <a:pPr algn="l">
-                <a:lnSpc>
-                  <a:spcPts val="2879"/>
-                </a:lnSpc>
-              </a:pPr>
-              <a:r>
-                <a:rPr lang="en-US" sz="2400" b="true">
-                  <a:solidFill>
-                    <a:srgbClr val="D9700F"/>
-                  </a:solidFill>
-                  <a:latin typeface="Courier New Bold"/>
-                  <a:ea typeface="Courier New Bold"/>
-                  <a:cs typeface="Courier New Bold"/>
-                  <a:sym typeface="Courier New Bold"/>
-                </a:rPr>
-                <a:t>03</a:t>
-              </a:r>
-            </a:p>
-          </p:txBody>
-        </p:sp>
-      </p:grpSp>
-      <p:grpSp>
-        <p:nvGrpSpPr>
-          <p:cNvPr name="Group 53" id="53"/>
-          <p:cNvGrpSpPr/>
-          <p:nvPr/>
-        </p:nvGrpSpPr>
-        <p:grpSpPr>
-          <a:xfrm rot="0">
-            <a:off x="2057400" y="6035040"/>
-            <a:ext cx="7749540" cy="431113"/>
-            <a:chOff x="0" y="0"/>
-            <a:chExt cx="10332720" cy="574817"/>
-          </a:xfrm>
-        </p:grpSpPr>
-        <p:sp>
-          <p:nvSpPr>
-            <p:cNvPr name="Freeform 54" id="54"/>
-            <p:cNvSpPr/>
-            <p:nvPr/>
-          </p:nvSpPr>
-          <p:spPr>
-            <a:xfrm flipH="false" flipV="false" rot="0">
-              <a:off x="0" y="0"/>
-              <a:ext cx="10332720" cy="574817"/>
-            </a:xfrm>
-            <a:custGeom>
-              <a:avLst/>
-              <a:gdLst/>
-              <a:ahLst/>
-              <a:cxnLst/>
-              <a:rect r="r" b="b" t="t" l="l"/>
-              <a:pathLst>
-                <a:path h="574817" w="10332720">
-                  <a:moveTo>
-                    <a:pt x="0" y="0"/>
-                  </a:moveTo>
-                  <a:lnTo>
-                    <a:pt x="10332720" y="0"/>
-                  </a:lnTo>
-                  <a:lnTo>
-                    <a:pt x="10332720" y="574817"/>
-                  </a:lnTo>
-                  <a:lnTo>
-                    <a:pt x="0" y="574817"/>
-                  </a:lnTo>
-                  <a:close/>
-                </a:path>
-              </a:pathLst>
-            </a:custGeom>
-            <a:blipFill>
-              <a:blip r:embed="rId3">
-                <a:alphaModFix amt="0"/>
-              </a:blip>
-              <a:stretch>
-                <a:fillRect l="0" t="-305715" r="0" b="-294797"/>
-              </a:stretch>
-            </a:blipFill>
-          </p:spPr>
-        </p:sp>
-        <p:sp>
-          <p:nvSpPr>
-            <p:cNvPr name="TextBox 55" id="55"/>
-            <p:cNvSpPr txBox="true"/>
-            <p:nvPr/>
-          </p:nvSpPr>
-          <p:spPr>
-            <a:xfrm>
-              <a:off x="0" y="-47625"/>
-              <a:ext cx="10332720" cy="622442"/>
-            </a:xfrm>
-            <a:prstGeom prst="rect">
-              <a:avLst/>
-            </a:prstGeom>
-          </p:spPr>
-          <p:txBody>
-            <a:bodyPr anchor="ctr" rtlCol="false" tIns="0" lIns="0" bIns="0" rIns="0"/>
-            <a:lstStyle/>
-            <a:p>
-              <a:pPr algn="l">
-                <a:lnSpc>
-                  <a:spcPts val="2609"/>
-                </a:lnSpc>
-              </a:pPr>
-              <a:r>
-                <a:rPr sz="2174" b="1">
-                  <a:solidFill>
-                    <a:srgbClr val="1F497D"/>
-                  </a:solidFill>
-                  <a:latin typeface="Calibri"/>
-                </a:rPr>
-                <a:t>UPC Spain &amp; Souli et al. (IEEE Access 2026 / Elsevier 2024)</a:t>
-              </a:r>
-            </a:p>
-          </p:txBody>
-        </p:sp>
-      </p:grpSp>
-      <p:sp>
-        <p:nvSpPr>
-          <p:cNvPr name="TextBox 56" id="56"/>
-          <p:cNvSpPr txBox="true"/>
-          <p:nvPr/>
-        </p:nvSpPr>
-        <p:spPr>
-          <a:xfrm rot="0">
-            <a:off x="2057400" y="6417945"/>
-            <a:ext cx="7749540" cy="1016127"/>
-          </a:xfrm>
-          <a:prstGeom prst="rect">
-            <a:avLst/>
-          </a:prstGeom>
-        </p:spPr>
-        <p:txBody>
-          <a:bodyPr anchor="t" rtlCol="false" tIns="0" lIns="0" bIns="0" rIns="0">
-            <a:spAutoFit/>
-          </a:bodyPr>
-          <a:lstStyle/>
-          <a:p>
-            <a:pPr algn="l" marL="298609" indent="-149304" lvl="1">
-              <a:lnSpc>
-                <a:spcPts val="1980"/>
-              </a:lnSpc>
-              <a:buFont typeface="Arial"/>
-              <a:buChar char="•"/>
-            </a:pPr>
-            <a:r>
-              <a:rPr sz="1550" i="1">
-                <a:solidFill>
-                  <a:srgbClr val="566074"/>
-                </a:solidFill>
-                <a:latin typeface="Calibri"/>
-              </a:rPr>
-              <a:t>• 'Long-Range BLE Detection via Drone LoRa Relays' &amp; 'Mission-Critical ROS-LoRa Architecture'</a:t>
-            </a:r>
-          </a:p>
-          <a:p>
-            <a:pPr algn="l" marL="298609" indent="-149304" lvl="1">
-              <a:lnSpc>
-                <a:spcPts val="1980"/>
-              </a:lnSpc>
-              <a:buFont typeface="Arial"/>
-              <a:buChar char="•"/>
-            </a:pPr>
-            <a:r>
-              <a:rPr sz="1550">
-                <a:solidFill>
-                  <a:srgbClr val="1E2638"/>
-                </a:solidFill>
-                <a:latin typeface="Calibri"/>
-              </a:rPr>
-              <a:t>• Sourced 868 MHz LoRa off-grid data bridge &amp; 17-byte binary telemetry in cellular blackout zones.</a:t>
-            </a:r>
-          </a:p>
-        </p:txBody>
-      </p:sp>
-      <p:grpSp>
-        <p:nvGrpSpPr>
-          <p:cNvPr name="Group 57" id="57"/>
-          <p:cNvGrpSpPr/>
-          <p:nvPr/>
-        </p:nvGrpSpPr>
-        <p:grpSpPr>
-          <a:xfrm rot="0">
-            <a:off x="815816" y="7618952"/>
-            <a:ext cx="9272588" cy="1550480"/>
-            <a:chOff x="0" y="0"/>
-            <a:chExt cx="12363450" cy="2067306"/>
-          </a:xfrm>
-        </p:grpSpPr>
-        <p:sp>
-          <p:nvSpPr>
-            <p:cNvPr name="Freeform 58" id="58"/>
-            <p:cNvSpPr/>
-            <p:nvPr/>
-          </p:nvSpPr>
-          <p:spPr>
-            <a:xfrm flipH="false" flipV="false" rot="0">
-              <a:off x="0" y="0"/>
-              <a:ext cx="12363450" cy="2067306"/>
-            </a:xfrm>
-            <a:custGeom>
-              <a:avLst/>
-              <a:gdLst/>
-              <a:ahLst/>
-              <a:cxnLst/>
-              <a:rect r="r" b="b" t="t" l="l"/>
-              <a:pathLst>
-                <a:path h="2067306" w="12363450">
-                  <a:moveTo>
-                    <a:pt x="0" y="221488"/>
-                  </a:moveTo>
-                  <a:cubicBezTo>
-                    <a:pt x="0" y="99187"/>
-                    <a:pt x="99187" y="0"/>
-                    <a:pt x="221488" y="0"/>
-                  </a:cubicBezTo>
-                  <a:lnTo>
-                    <a:pt x="12141962" y="0"/>
-                  </a:lnTo>
-                  <a:cubicBezTo>
-                    <a:pt x="12264263" y="0"/>
-                    <a:pt x="12363450" y="99187"/>
-                    <a:pt x="12363450" y="221488"/>
-                  </a:cubicBezTo>
-                  <a:lnTo>
-                    <a:pt x="12363450" y="1845818"/>
-                  </a:lnTo>
-                  <a:cubicBezTo>
-                    <a:pt x="12363450" y="1968119"/>
-                    <a:pt x="12264263" y="2067306"/>
-                    <a:pt x="12141962" y="2067306"/>
-                  </a:cubicBezTo>
-                  <a:lnTo>
-                    <a:pt x="221488" y="2067306"/>
-                  </a:lnTo>
-                  <a:cubicBezTo>
-                    <a:pt x="99187" y="2067306"/>
-                    <a:pt x="0" y="1968119"/>
-                    <a:pt x="0" y="1845818"/>
-                  </a:cubicBezTo>
-                  <a:close/>
-                </a:path>
-              </a:pathLst>
-            </a:custGeom>
-            <a:solidFill>
-              <a:srgbClr val="F4F8FC"/>
-            </a:solidFill>
-            <a:ln w="14288" cap="sq">
-              <a:solidFill>
-                <a:srgbClr val="D6E1EE"/>
-              </a:solidFill>
-              <a:prstDash val="solid"/>
-              <a:miter/>
-            </a:ln>
-          </p:spPr>
-        </p:sp>
-      </p:grpSp>
-      <p:grpSp>
-        <p:nvGrpSpPr>
-          <p:cNvPr name="Group 59" id="59"/>
-          <p:cNvGrpSpPr/>
-          <p:nvPr/>
-        </p:nvGrpSpPr>
-        <p:grpSpPr>
-          <a:xfrm rot="0">
-            <a:off x="1124712" y="7763256"/>
-            <a:ext cx="822960" cy="411480"/>
-            <a:chOff x="0" y="0"/>
-            <a:chExt cx="1097280" cy="548640"/>
-          </a:xfrm>
-        </p:grpSpPr>
-        <p:sp>
-          <p:nvSpPr>
-            <p:cNvPr name="Freeform 60" id="60"/>
-            <p:cNvSpPr/>
-            <p:nvPr/>
-          </p:nvSpPr>
-          <p:spPr>
-            <a:xfrm flipH="false" flipV="false" rot="0">
-              <a:off x="0" y="0"/>
-              <a:ext cx="1097280" cy="548640"/>
-            </a:xfrm>
-            <a:custGeom>
-              <a:avLst/>
-              <a:gdLst/>
-              <a:ahLst/>
-              <a:cxnLst/>
-              <a:rect r="r" b="b" t="t" l="l"/>
-              <a:pathLst>
-                <a:path h="548640" w="1097280">
-                  <a:moveTo>
-                    <a:pt x="0" y="0"/>
-                  </a:moveTo>
-                  <a:lnTo>
-                    <a:pt x="1097280" y="0"/>
-                  </a:lnTo>
-                  <a:lnTo>
-                    <a:pt x="1097280" y="548640"/>
-                  </a:lnTo>
-                  <a:lnTo>
-                    <a:pt x="0" y="548640"/>
-                  </a:lnTo>
-                  <a:close/>
-                </a:path>
-              </a:pathLst>
-            </a:custGeom>
-            <a:blipFill>
-              <a:blip r:embed="rId3">
-                <a:alphaModFix amt="0"/>
-              </a:blip>
-              <a:stretch>
-                <a:fillRect l="-14151" t="0" r="-14151" b="0"/>
-              </a:stretch>
-            </a:blipFill>
-          </p:spPr>
-        </p:sp>
-        <p:sp>
-          <p:nvSpPr>
-            <p:cNvPr name="TextBox 61" id="61"/>
-            <p:cNvSpPr txBox="true"/>
-            <p:nvPr/>
-          </p:nvSpPr>
-          <p:spPr>
-            <a:xfrm>
-              <a:off x="0" y="-9525"/>
-              <a:ext cx="1097280" cy="558165"/>
-            </a:xfrm>
-            <a:prstGeom prst="rect">
-              <a:avLst/>
-            </a:prstGeom>
-          </p:spPr>
-          <p:txBody>
-            <a:bodyPr anchor="ctr" rtlCol="false" tIns="0" lIns="0" bIns="0" rIns="0"/>
-            <a:lstStyle/>
-            <a:p>
-              <a:pPr algn="l">
-                <a:lnSpc>
-                  <a:spcPts val="2879"/>
-                </a:lnSpc>
-              </a:pPr>
-              <a:r>
-                <a:rPr lang="en-US" sz="2400" b="true">
-                  <a:solidFill>
-                    <a:srgbClr val="D9700F"/>
-                  </a:solidFill>
-                  <a:latin typeface="Courier New Bold"/>
-                  <a:ea typeface="Courier New Bold"/>
-                  <a:cs typeface="Courier New Bold"/>
-                  <a:sym typeface="Courier New Bold"/>
-                </a:rPr>
-                <a:t>04</a:t>
-              </a:r>
-            </a:p>
-          </p:txBody>
-        </p:sp>
-      </p:grpSp>
-      <p:grpSp>
-        <p:nvGrpSpPr>
-          <p:cNvPr name="Group 62" id="62"/>
-          <p:cNvGrpSpPr/>
-          <p:nvPr/>
-        </p:nvGrpSpPr>
-        <p:grpSpPr>
-          <a:xfrm rot="0">
-            <a:off x="2057400" y="7735824"/>
-            <a:ext cx="7749540" cy="431113"/>
-            <a:chOff x="0" y="0"/>
-            <a:chExt cx="10332720" cy="574817"/>
-          </a:xfrm>
-        </p:grpSpPr>
-        <p:sp>
-          <p:nvSpPr>
-            <p:cNvPr name="Freeform 63" id="63"/>
-            <p:cNvSpPr/>
-            <p:nvPr/>
-          </p:nvSpPr>
-          <p:spPr>
-            <a:xfrm flipH="false" flipV="false" rot="0">
-              <a:off x="0" y="0"/>
-              <a:ext cx="10332720" cy="574817"/>
-            </a:xfrm>
-            <a:custGeom>
-              <a:avLst/>
-              <a:gdLst/>
-              <a:ahLst/>
-              <a:cxnLst/>
-              <a:rect r="r" b="b" t="t" l="l"/>
-              <a:pathLst>
-                <a:path h="574817" w="10332720">
-                  <a:moveTo>
-                    <a:pt x="0" y="0"/>
-                  </a:moveTo>
-                  <a:lnTo>
-                    <a:pt x="10332720" y="0"/>
-                  </a:lnTo>
-                  <a:lnTo>
-                    <a:pt x="10332720" y="574817"/>
-                  </a:lnTo>
-                  <a:lnTo>
-                    <a:pt x="0" y="574817"/>
-                  </a:lnTo>
-                  <a:close/>
-                </a:path>
-              </a:pathLst>
-            </a:custGeom>
-            <a:blipFill>
-              <a:blip r:embed="rId3">
-                <a:alphaModFix amt="0"/>
-              </a:blip>
-              <a:stretch>
-                <a:fillRect l="0" t="-305715" r="0" b="-294797"/>
-              </a:stretch>
-            </a:blipFill>
-          </p:spPr>
-        </p:sp>
-        <p:sp>
-          <p:nvSpPr>
-            <p:cNvPr name="TextBox 64" id="64"/>
-            <p:cNvSpPr txBox="true"/>
-            <p:nvPr/>
-          </p:nvSpPr>
-          <p:spPr>
-            <a:xfrm>
-              <a:off x="0" y="-47625"/>
-              <a:ext cx="10332720" cy="622442"/>
-            </a:xfrm>
-            <a:prstGeom prst="rect">
-              <a:avLst/>
-            </a:prstGeom>
-          </p:spPr>
-          <p:txBody>
-            <a:bodyPr anchor="ctr" rtlCol="false" tIns="0" lIns="0" bIns="0" rIns="0"/>
-            <a:lstStyle/>
-            <a:p>
-              <a:pPr algn="l">
-                <a:lnSpc>
-                  <a:spcPts val="2609"/>
-                </a:lnSpc>
-              </a:pPr>
-              <a:r>
-                <a:rPr sz="2174" b="1">
-                  <a:solidFill>
-                    <a:srgbClr val="1F497D"/>
-                  </a:solidFill>
-                  <a:latin typeface="Calibri"/>
-                </a:rPr>
-                <a:t>TalTech Estonia (IEEE Access, 2023)</a:t>
-              </a:r>
-            </a:p>
-          </p:txBody>
-        </p:sp>
-      </p:grpSp>
-      <p:sp>
-        <p:nvSpPr>
-          <p:cNvPr name="TextBox 65" id="65"/>
-          <p:cNvSpPr txBox="true"/>
-          <p:nvPr/>
-        </p:nvSpPr>
-        <p:spPr>
-          <a:xfrm rot="0">
-            <a:off x="2057400" y="8118729"/>
-            <a:ext cx="7749540" cy="1016127"/>
-          </a:xfrm>
-          <a:prstGeom prst="rect">
-            <a:avLst/>
-          </a:prstGeom>
-        </p:spPr>
-        <p:txBody>
-          <a:bodyPr anchor="t" rtlCol="false" tIns="0" lIns="0" bIns="0" rIns="0">
-            <a:spAutoFit/>
-          </a:bodyPr>
-          <a:lstStyle/>
-          <a:p>
-            <a:pPr algn="l" marL="298609" indent="-149304" lvl="1">
-              <a:lnSpc>
-                <a:spcPts val="1980"/>
-              </a:lnSpc>
-              <a:buFont typeface="Arial"/>
-              <a:buChar char="•"/>
-            </a:pPr>
-            <a:r>
-              <a:rPr sz="1550" i="1">
-                <a:solidFill>
-                  <a:srgbClr val="566074"/>
-                </a:solidFill>
-                <a:latin typeface="Calibri"/>
-              </a:rPr>
-              <a:t>• 'Applying RIS-Based Communication for Collaborative Computing in a Swarm of Drones'</a:t>
-            </a:r>
-          </a:p>
-          <a:p>
-            <a:pPr algn="l" marL="298609" indent="-149304" lvl="1">
-              <a:lnSpc>
-                <a:spcPts val="1980"/>
-              </a:lnSpc>
-              <a:buFont typeface="Arial"/>
-              <a:buChar char="•"/>
-            </a:pPr>
-            <a:r>
-              <a:rPr sz="1550">
-                <a:solidFill>
-                  <a:srgbClr val="1E2638"/>
-                </a:solidFill>
-                <a:latin typeface="Calibri"/>
-              </a:rPr>
-              <a:t>• Validated decentralized swarm edge-computing without cloud servers (-32% energy, -18% latency).</a:t>
+              <a:t>• Sourced 12-state rigid-body dynamics, 90/10 electrical propulsion ratio, and anti-windup integrator.</a:t>
             </a:r>
           </a:p>
         </p:txBody>

</xml_diff>

<commit_message>
fix: correct VIO attribution, Dijkstra phrasing, BOM cost alignment, video placeholder
</commit_message>
<xml_diff>
--- a/Copy of SIH26177_v6.pptx.pptx
+++ b/Copy of SIH26177_v6.pptx.pptx
@@ -13074,6 +13074,10 @@
             </a:stretch>
           </a:blipFill>
         </p:spPr>
+        <p:txBody>
+          <a:bodyPr/>
+          <a:p/>
+        </p:txBody>
       </p:sp>
       <p:sp>
         <p:nvSpPr>
@@ -13638,16 +13642,13 @@
               </a:lnSpc>
             </a:pPr>
             <a:r>
-              <a:rPr lang="en-US" sz="1575">
+              <a:rPr sz="1650">
                 <a:solidFill>
                   <a:srgbClr val="1E2638"/>
                 </a:solidFill>
-                <a:latin typeface="Calibri (MS)"/>
-                <a:ea typeface="Calibri (MS)"/>
-                <a:cs typeface="Calibri (MS)"/>
-                <a:sym typeface="Calibri (MS)"/>
+                <a:latin typeface="Calibri"/>
               </a:rPr>
-              <a:t>Visual Odometry heading overrides magnetometer in steel rubble (Bouabdallah 2007).</a:t>
+              <a:t>Visual-Inertial Odometry overrides magnetometer in collapsed steel rubble (IEEE).</a:t>
             </a:r>
           </a:p>
         </p:txBody>
@@ -14526,6 +14527,10 @@
             <a:tailEnd type="none" len="sm" w="sm"/>
           </a:ln>
         </p:spPr>
+        <p:txBody>
+          <a:bodyPr/>
+          <a:p/>
+        </p:txBody>
       </p:sp>
       <p:grpSp>
         <p:nvGrpSpPr>
@@ -14855,6 +14860,10 @@
             <a:tailEnd type="none" len="sm" w="sm"/>
           </a:ln>
         </p:spPr>
+        <p:txBody>
+          <a:bodyPr/>
+          <a:p/>
+        </p:txBody>
       </p:sp>
       <p:grpSp>
         <p:nvGrpSpPr>
@@ -15184,6 +15193,10 @@
             <a:tailEnd type="none" len="sm" w="sm"/>
           </a:ln>
         </p:spPr>
+        <p:txBody>
+          <a:bodyPr/>
+          <a:p/>
+        </p:txBody>
       </p:sp>
       <p:grpSp>
         <p:nvGrpSpPr>
@@ -15513,6 +15526,10 @@
             <a:tailEnd type="none" len="sm" w="sm"/>
           </a:ln>
         </p:spPr>
+        <p:txBody>
+          <a:bodyPr/>
+          <a:p/>
+        </p:txBody>
       </p:sp>
       <p:grpSp>
         <p:nvGrpSpPr>
@@ -15842,6 +15859,10 @@
             <a:tailEnd type="none" len="sm" w="sm"/>
           </a:ln>
         </p:spPr>
+        <p:txBody>
+          <a:bodyPr/>
+          <a:p/>
+        </p:txBody>
       </p:sp>
       <p:grpSp>
         <p:nvGrpSpPr>
@@ -16439,16 +16460,13 @@
               </a:lnSpc>
             </a:pPr>
             <a:r>
-              <a:rPr lang="en-US" sz="1525">
+              <a:rPr sz="1650">
                 <a:solidFill>
                   <a:srgbClr val="1E2638"/>
                 </a:solidFill>
-                <a:latin typeface="Calibri (MS)"/>
-                <a:ea typeface="Calibri (MS)"/>
-                <a:cs typeface="Calibri (MS)"/>
-                <a:sym typeface="Calibri (MS)"/>
+                <a:latin typeface="Calibri"/>
               </a:rPr>
-              <a:t>Ground station ranks victims by accessibility, and can use the Dijkstra algorithm hazard-free ground efficient route.</a:t>
+              <a:t>Offline GCS computes priority triage queue and charts a hazard-aware Dijkstra safe walking corridor avoiding live wires directly to casualty.</a:t>
             </a:r>
           </a:p>
         </p:txBody>
@@ -21191,61 +21209,24 @@
               <a:buChar char="•"/>
             </a:pPr>
             <a:r>
-              <a:rPr lang="en-US" b="true" sz="1725">
-                <a:solidFill>
-                  <a:srgbClr val="1F497D"/>
-                </a:solidFill>
-                <a:latin typeface="Calibri (MS) Bold"/>
-                <a:ea typeface="Calibri (MS) Bold"/>
-                <a:cs typeface="Calibri (MS) Bold"/>
-                <a:sym typeface="Calibri (MS) Bold"/>
-              </a:rPr>
-              <a:t>Prototype cost: </a:t>
-            </a:r>
-            <a:r>
-              <a:rPr lang="en-US" sz="1725">
+              <a:rPr sz="1650">
                 <a:solidFill>
                   <a:srgbClr val="1E2638"/>
                 </a:solidFill>
-                <a:latin typeface="Calibri (MS)"/>
-                <a:ea typeface="Calibri (MS)"/>
-                <a:cs typeface="Calibri (MS)"/>
-                <a:sym typeface="Calibri (MS)"/>
+                <a:latin typeface="Calibri"/>
               </a:rPr>
-              <a:t>20,000₹</a:t>
+              <a:t>Prototype Build: ₹35,800 (Calibrated Functional Prototype).</a:t>
             </a:r>
           </a:p>
           <a:p>
-            <a:pPr algn="l" marL="312182" indent="-156091" lvl="1">
-              <a:lnSpc>
-                <a:spcPts val="2070"/>
-              </a:lnSpc>
-              <a:buFont typeface="Arial"/>
-              <a:buChar char="•"/>
-            </a:pPr>
             <a:r>
-              <a:rPr lang="en-US" b="true" sz="1725">
-                <a:solidFill>
-                  <a:srgbClr val="1F497D"/>
-                </a:solidFill>
-                <a:latin typeface="Calibri (MS) Bold"/>
-                <a:ea typeface="Calibri (MS) Bold"/>
-                <a:cs typeface="Calibri (MS) Bold"/>
-                <a:sym typeface="Calibri (MS) Bold"/>
-              </a:rPr>
-              <a:t>Bill of Materials: </a:t>
-            </a:r>
-            <a:r>
-              <a:rPr lang="en-US" sz="1725">
+              <a:rPr sz="1650">
                 <a:solidFill>
                   <a:srgbClr val="1E2638"/>
                 </a:solidFill>
-                <a:latin typeface="Calibri (MS)"/>
-                <a:ea typeface="Calibri (MS)"/>
-                <a:cs typeface="Calibri (MS)"/>
-                <a:sym typeface="Calibri (MS)"/>
+                <a:latin typeface="Calibri"/>
               </a:rPr>
-              <a:t>₹85,000 – ₹1,40,000 per operational unit.</a:t>
+              <a:t>Production BOM: ₹85,000 – ₹1,20,000 per unit (10x cheaper than commercial enterprise drones).</a:t>
             </a:r>
           </a:p>
         </p:txBody>
@@ -32862,6 +32843,20 @@
             <a:tailEnd type="none" len="sm" w="sm"/>
           </a:ln>
         </p:spPr>
+        <p:txBody>
+          <a:bodyPr/>
+          <a:p>
+            <a:r>
+              <a:rPr sz="1300" i="1">
+                <a:solidFill>
+                  <a:srgbClr val="788296"/>
+                </a:solidFill>
+                <a:latin typeface="Calibri"/>
+              </a:rPr>
+              <a:t>Video link: SIH Grand Finale Submission Portal</a:t>
+            </a:r>
+          </a:p>
+        </p:txBody>
       </p:sp>
       <p:grpSp>
         <p:nvGrpSpPr>

</xml_diff>

<commit_message>
feat: add SARDO (IEEE TMC 2022) and Mishra et al. (Elsevier 2020) as secondary citations on Slide 6
</commit_message>
<xml_diff>
--- a/Copy of SIH26177_v6.pptx.pptx
+++ b/Copy of SIH26177_v6.pptx.pptx
@@ -32309,6 +32309,26 @@
               <a:t>• Validated decentralized swarm edge-computing without cloud servers (-32% energy, -18% latency).</a:t>
             </a:r>
           </a:p>
+          <a:p>
+            <a:r>
+              <a:rPr sz="1400" b="1" i="0">
+                <a:solidFill>
+                  <a:srgbClr val="B35A00"/>
+                </a:solidFill>
+                <a:latin typeface="Calibri"/>
+              </a:rPr>
+              <a:t>Also cited: </a:t>
+            </a:r>
+            <a:r>
+              <a:rPr sz="1400" b="0" i="1">
+                <a:solidFill>
+                  <a:srgbClr val="566074"/>
+                </a:solidFill>
+                <a:latin typeface="Calibri"/>
+              </a:rPr>
+              <a:t>Albanese et al., SARDO — Automated SDR-based Victim Localization, IEEE TMC, 2022. Baseline comparison: Phoenix X achieves equivalent victim localization at 1/8th payload weight.</a:t>
+            </a:r>
+          </a:p>
         </p:txBody>
       </p:sp>
       <p:grpSp>
@@ -32635,6 +32655,26 @@
                 <a:latin typeface="Calibri"/>
               </a:rPr>
               <a:t>• Sourced 12-state rigid-body dynamics, 90/10 electrical propulsion ratio, and anti-windup integrator.</a:t>
+            </a:r>
+          </a:p>
+          <a:p>
+            <a:r>
+              <a:rPr sz="1400" b="1" i="0">
+                <a:solidFill>
+                  <a:srgbClr val="B35A00"/>
+                </a:solidFill>
+                <a:latin typeface="Calibri"/>
+              </a:rPr>
+              <a:t>Also cited: </a:t>
+            </a:r>
+            <a:r>
+              <a:rPr sz="1400" b="0" i="1">
+                <a:solidFill>
+                  <a:srgbClr val="566074"/>
+                </a:solidFill>
+                <a:latin typeface="Calibri"/>
+              </a:rPr>
+              <a:t>Mishra et al. (BITS Pilani &amp; Bennett Univ.), CNN-Based Aerial Human Action Detection, Elsevier Computer Communications, Vol. 156, 2020. Validates Phoenix X's YOLOv8n multi-spectral aerial detection pipeline.</a:t>
             </a:r>
           </a:p>
         </p:txBody>

</xml_diff>

<commit_message>
fix: compact 'Also cited' lines to 12pt to prevent card overflow on Slide 6
</commit_message>
<xml_diff>
--- a/Copy of SIH26177_v6.pptx.pptx
+++ b/Copy of SIH26177_v6.pptx.pptx
@@ -32300,7 +32300,7 @@
           </a:p>
           <a:p>
             <a:r>
-              <a:rPr sz="1550">
+              <a:rPr sz="1550" i="0">
                 <a:solidFill>
                   <a:srgbClr val="1E2638"/>
                 </a:solidFill>
@@ -32311,7 +32311,7 @@
           </a:p>
           <a:p>
             <a:r>
-              <a:rPr sz="1400" b="1" i="0">
+              <a:rPr sz="1200" b="1">
                 <a:solidFill>
                   <a:srgbClr val="B35A00"/>
                 </a:solidFill>
@@ -32320,13 +32320,13 @@
               <a:t>Also cited: </a:t>
             </a:r>
             <a:r>
-              <a:rPr sz="1400" b="0" i="1">
+              <a:rPr sz="1200" i="1">
                 <a:solidFill>
                   <a:srgbClr val="566074"/>
                 </a:solidFill>
                 <a:latin typeface="Calibri"/>
               </a:rPr>
-              <a:t>Albanese et al., SARDO — Automated SDR-based Victim Localization, IEEE TMC, 2022. Baseline comparison: Phoenix X achieves equivalent victim localization at 1/8th payload weight.</a:t>
+              <a:t>Albanese et al., SARDO — SDR victim localization baseline (IEEE TMC, 2022). Phoenix X: equivalent accuracy at 1/8th payload.</a:t>
             </a:r>
           </a:p>
         </p:txBody>
@@ -32648,7 +32648,7 @@
           </a:p>
           <a:p>
             <a:r>
-              <a:rPr sz="1550">
+              <a:rPr sz="1550" i="0">
                 <a:solidFill>
                   <a:srgbClr val="1E2638"/>
                 </a:solidFill>
@@ -32659,7 +32659,7 @@
           </a:p>
           <a:p>
             <a:r>
-              <a:rPr sz="1400" b="1" i="0">
+              <a:rPr sz="1200" b="1">
                 <a:solidFill>
                   <a:srgbClr val="B35A00"/>
                 </a:solidFill>
@@ -32668,13 +32668,13 @@
               <a:t>Also cited: </a:t>
             </a:r>
             <a:r>
-              <a:rPr sz="1400" b="0" i="1">
+              <a:rPr sz="1200" i="1">
                 <a:solidFill>
                   <a:srgbClr val="566074"/>
                 </a:solidFill>
                 <a:latin typeface="Calibri"/>
               </a:rPr>
-              <a:t>Mishra et al. (BITS Pilani &amp; Bennett Univ.), CNN-Based Aerial Human Action Detection, Elsevier Computer Communications, Vol. 156, 2020. Validates Phoenix X's YOLOv8n multi-spectral aerial detection pipeline.</a:t>
+              <a:t>Mishra et al. (BITS Pilani &amp; Bennett Univ.) — CNN aerial detection dataset (Elsevier Comp. Comm., 2020).</a:t>
             </a:r>
           </a:p>
         </p:txBody>

</xml_diff>

<commit_message>
feat: emphasize sweep mechanics, offset geolocation math, and YOLO survivor+obstacle avoidance
</commit_message>
<xml_diff>
--- a/Copy of SIH26177_v6.pptx.pptx
+++ b/Copy of SIH26177_v6.pptx.pptx
@@ -13519,16 +13519,13 @@
               </a:lnSpc>
             </a:pPr>
             <a:r>
-              <a:rPr lang="en-US" sz="1575">
+              <a:rPr sz="1650">
                 <a:solidFill>
                   <a:srgbClr val="1E2638"/>
                 </a:solidFill>
-                <a:latin typeface="Calibri (MS)"/>
-                <a:ea typeface="Calibri (MS)"/>
-                <a:cs typeface="Calibri (MS)"/>
-                <a:sym typeface="Calibri (MS)"/>
+                <a:latin typeface="Calibri"/>
               </a:rPr>
-              <a:t>INT8 quantized neural model running on NPU; preserves 90% power for flight.</a:t>
+              <a:t>INT8 YOLO identifies victims &amp; flight obstacles on Qualcomm NPU; preserves 90% power for rotors.</a:t>
             </a:r>
           </a:p>
         </p:txBody>
@@ -15156,16 +15153,13 @@
               </a:lnSpc>
             </a:pPr>
             <a:r>
-              <a:rPr lang="en-US" sz="1525">
+              <a:rPr sz="1525">
                 <a:solidFill>
                   <a:srgbClr val="1E2638"/>
                 </a:solidFill>
-                <a:latin typeface="Calibri (MS)"/>
-                <a:ea typeface="Calibri (MS)"/>
-                <a:cs typeface="Calibri (MS)"/>
-                <a:sym typeface="Calibri (MS)"/>
+                <a:latin typeface="Calibri"/>
               </a:rPr>
-              <a:t>Executes Boustrophedon lawnmower coverage flight powered by STM32U5 / Zephyr RTOS at 250 Hz.</a:t>
+              <a:t>Boustrophedon decomposition with 60% sidelap &amp; 70% overlap; ToF altimeter maintains constant GSD over sloped terrain.</a:t>
             </a:r>
           </a:p>
         </p:txBody>
@@ -15489,16 +15483,13 @@
               </a:lnSpc>
             </a:pPr>
             <a:r>
-              <a:rPr lang="en-US" sz="1525">
+              <a:rPr sz="1525">
                 <a:solidFill>
                   <a:srgbClr val="1E2638"/>
                 </a:solidFill>
-                <a:latin typeface="Calibri (MS)"/>
-                <a:ea typeface="Calibri (MS)"/>
-                <a:cs typeface="Calibri (MS)"/>
-                <a:sym typeface="Calibri (MS)"/>
+                <a:latin typeface="Calibri"/>
               </a:rPr>
-              <a:t>Dual 4K RGB + LWIR Thermal cameras co-register frames; edge YOLO extracts human heat contours.</a:t>
+              <a:t>Dual 4K RGB + LWIR Thermal fusion; edge YOLO identifies survivor heat contours (37°C) &amp; flags obstacles for flight avoidance.</a:t>
             </a:r>
           </a:p>
         </p:txBody>
@@ -15822,16 +15813,13 @@
               </a:lnSpc>
             </a:pPr>
             <a:r>
-              <a:rPr lang="en-US" sz="1525">
+              <a:rPr sz="1525">
                 <a:solidFill>
                   <a:srgbClr val="1E2638"/>
                 </a:solidFill>
-                <a:latin typeface="Calibri (MS)"/>
-                <a:ea typeface="Calibri (MS)"/>
-                <a:cs typeface="Calibri (MS)"/>
-                <a:sym typeface="Calibri (MS)"/>
+                <a:latin typeface="Calibri"/>
               </a:rPr>
-              <a:t>Tait-Bryan DCM matrix converts bounding box center + LiDAR altitude into real-world Lat/Long.</a:t>
+              <a:t>Transforms 2D bbox offset via 3D Tait-Bryan DCM matrix &amp; ToF altitude (ΔP = H_AGL · R·v) to pin GPS on the fly.</a:t>
             </a:r>
           </a:p>
         </p:txBody>
@@ -17471,35 +17459,22 @@
               <a:buChar char="•"/>
             </a:pPr>
             <a:r>
-              <a:rPr lang="en-US" sz="1289">
+              <a:rPr sz="1289">
                 <a:solidFill>
                   <a:srgbClr val="E4ECF7"/>
                 </a:solidFill>
-                <a:latin typeface="Calibri (MS)"/>
-                <a:ea typeface="Calibri (MS)"/>
-                <a:cs typeface="Calibri (MS)"/>
-                <a:sym typeface="Calibri (MS)"/>
+                <a:latin typeface="Calibri"/>
               </a:rPr>
-              <a:t>INT8 YOLO Edge AI + Optical-to-Ground Ray-Caster</a:t>
+              <a:t>Dual-Task INT8 YOLO (Survivor Triage + Flight Obstacle Avoidance) // Ray-Caster</a:t>
             </a:r>
           </a:p>
           <a:p>
-            <a:pPr algn="l" marL="233447" indent="-116723" lvl="1">
-              <a:lnSpc>
-                <a:spcPts val="1547"/>
-              </a:lnSpc>
-              <a:buFont typeface="Arial"/>
-              <a:buChar char="•"/>
-            </a:pPr>
             <a:r>
-              <a:rPr lang="en-US" sz="1289">
+              <a:rPr sz="1289">
                 <a:solidFill>
                   <a:srgbClr val="E4ECF7"/>
                 </a:solidFill>
-                <a:latin typeface="Calibri (MS)"/>
-                <a:ea typeface="Calibri (MS)"/>
-                <a:cs typeface="Calibri (MS)"/>
-                <a:sym typeface="Calibri (MS)"/>
+                <a:latin typeface="Calibri"/>
               </a:rPr>
               <a:t>Semtech SX1262 LoRa Telemetry Driver (868 MHz)</a:t>
             </a:r>
@@ -18164,16 +18139,13 @@
                 </a:lnSpc>
               </a:pPr>
               <a:r>
-                <a:rPr lang="en-US" sz="1450">
+                <a:rPr sz="1400">
                   <a:solidFill>
                     <a:srgbClr val="1E2638"/>
                   </a:solidFill>
-                  <a:latin typeface="Calibri (MS)"/>
-                  <a:ea typeface="Calibri (MS)"/>
-                  <a:cs typeface="Calibri (MS)"/>
-                  <a:sym typeface="Calibri (MS)"/>
+                  <a:latin typeface="Calibri"/>
                 </a:rPr>
-                <a:t>Qualcomm SNPE, ONNX Runtime INT8, OpenCV</a:t>
+                <a:t>YOLOv8n INT8 (Detection &amp; Avoidance), SNPE, OpenCV</a:t>
               </a:r>
             </a:p>
           </p:txBody>

</xml_diff>

<commit_message>
feat: emphasize 100% onboard dual-brain compute and zero ground GPU burden across slides 2, 3, 4
</commit_message>
<xml_diff>
--- a/Copy of SIH26177_v6.pptx.pptx
+++ b/Copy of SIH26177_v6.pptx.pptx
@@ -13326,28 +13326,22 @@
               <a:buChar char="•"/>
             </a:pPr>
             <a:r>
-              <a:rPr lang="en-US" b="true" sz="1625">
+              <a:rPr sz="1625" b="1">
                 <a:solidFill>
-                  <a:srgbClr val="FFB35C"/>
+                  <a:srgbClr val="1E2638"/>
                 </a:solidFill>
-                <a:latin typeface="Calibri (MS) Bold"/>
-                <a:ea typeface="Calibri (MS) Bold"/>
-                <a:cs typeface="Calibri (MS) Bold"/>
-                <a:sym typeface="Calibri (MS) Bold"/>
+                <a:latin typeface="Calibri"/>
               </a:rPr>
-              <a:t>100% ON-DEVICE AI: </a:t>
+              <a:t>100% ONBOARD EDGE COMPUTE: </a:t>
             </a:r>
             <a:r>
-              <a:rPr lang="en-US" sz="1625">
+              <a:rPr sz="1625">
                 <a:solidFill>
-                  <a:srgbClr val="E4ECF7"/>
+                  <a:srgbClr val="1E2638"/>
                 </a:solidFill>
-                <a:latin typeface="Calibri (MS)"/>
-                <a:ea typeface="Calibri (MS)"/>
-                <a:cs typeface="Calibri (MS)"/>
-                <a:sym typeface="Calibri (MS)"/>
+                <a:latin typeface="Calibri"/>
               </a:rPr>
-              <a:t>Executes real-time vision on Qualcomm silicon without internet.</a:t>
+              <a:t>All AI vision, sensor fusion &amp; geolocation execute on UAV silicon; zero reliance on ground GPUs or cloud.</a:t>
             </a:r>
           </a:p>
           <a:p>
@@ -13425,28 +13419,22 @@
               <a:buChar char="•"/>
             </a:pPr>
             <a:r>
-              <a:rPr lang="en-US" b="true" sz="1625">
+              <a:rPr sz="1625" b="1">
                 <a:solidFill>
-                  <a:srgbClr val="FFB35C"/>
+                  <a:srgbClr val="1E2638"/>
                 </a:solidFill>
-                <a:latin typeface="Calibri (MS) Bold"/>
-                <a:ea typeface="Calibri (MS) Bold"/>
-                <a:cs typeface="Calibri (MS) Bold"/>
-                <a:sym typeface="Calibri (MS) Bold"/>
+                <a:latin typeface="Calibri"/>
               </a:rPr>
-              <a:t>OFFLINE TACTICAL GCS: </a:t>
+              <a:t>LIGHTWEIGHT OFFLINE GCS: </a:t>
             </a:r>
             <a:r>
-              <a:rPr lang="en-US" sz="1625">
+              <a:rPr sz="1625">
                 <a:solidFill>
-                  <a:srgbClr val="E4ECF7"/>
+                  <a:srgbClr val="1E2638"/>
                 </a:solidFill>
-                <a:latin typeface="Calibri (MS)"/>
-                <a:ea typeface="Calibri (MS)"/>
-                <a:cs typeface="Calibri (MS)"/>
-                <a:sym typeface="Calibri (MS)"/>
+                <a:latin typeface="Calibri"/>
               </a:rPr>
-              <a:t>Streams priority triage queues and safe rescue routes to local operators.</a:t>
+              <a:t>Low-power field tablets receive 17-byte pins; charts priority triage queues &amp; safe walking corridors.</a:t>
             </a:r>
           </a:p>
         </p:txBody>
@@ -16143,16 +16131,13 @@
               </a:lnSpc>
             </a:pPr>
             <a:r>
-              <a:rPr lang="en-US" sz="1525">
+              <a:rPr sz="1525">
                 <a:solidFill>
                   <a:srgbClr val="1E2638"/>
                 </a:solidFill>
-                <a:latin typeface="Calibri (MS)"/>
-                <a:ea typeface="Calibri (MS)"/>
-                <a:cs typeface="Calibri (MS)"/>
-                <a:sym typeface="Calibri (MS)"/>
+                <a:latin typeface="Calibri"/>
               </a:rPr>
-              <a:t>Souli et al. (2024) protocol packs survivor coordinates into 17-byte binary frame; broadcasts over 5+ km.</a:t>
+              <a:t>Onboard Triage &amp; LoRa Burst: UAV computes victim priority on-chip &amp; packs coordinates into 17-byte binary frame; broadcasts over 5+ km.</a:t>
             </a:r>
           </a:p>
         </p:txBody>
@@ -16448,13 +16433,13 @@
               </a:lnSpc>
             </a:pPr>
             <a:r>
-              <a:rPr sz="1650">
+              <a:rPr sz="1525">
                 <a:solidFill>
                   <a:srgbClr val="1E2638"/>
                 </a:solidFill>
                 <a:latin typeface="Calibri"/>
               </a:rPr>
-              <a:t>Offline GCS computes priority triage queue and charts a hazard-aware Dijkstra safe walking corridor avoiding live wires directly to casualty.</a:t>
+              <a:t>Lightweight Offline GCS: Low-power tablet receives 17-byte pins; charts hazard-aware Dijkstra safe walking corridor avoiding live wires.</a:t>
             </a:r>
           </a:p>
         </p:txBody>
@@ -20867,61 +20852,35 @@
               <a:buChar char="•"/>
             </a:pPr>
             <a:r>
-              <a:rPr lang="en-US" b="true" sz="1725">
-                <a:solidFill>
-                  <a:srgbClr val="1F497D"/>
-                </a:solidFill>
-                <a:latin typeface="Calibri (MS) Bold"/>
-                <a:ea typeface="Calibri (MS) Bold"/>
-                <a:cs typeface="Calibri (MS) Bold"/>
-                <a:sym typeface="Calibri (MS) Bold"/>
-              </a:rPr>
-              <a:t>Setup Time: </a:t>
-            </a:r>
-            <a:r>
-              <a:rPr lang="en-US" sz="1725">
+              <a:rPr sz="1550">
                 <a:solidFill>
                   <a:srgbClr val="1E2638"/>
                 </a:solidFill>
-                <a:latin typeface="Calibri (MS)"/>
-                <a:ea typeface="Calibri (MS)"/>
-                <a:cs typeface="Calibri (MS)"/>
-                <a:sym typeface="Calibri (MS)"/>
+                <a:latin typeface="Calibri"/>
               </a:rPr>
-              <a:t>&lt; 3 minutes from rugged backpack unboxing to flight.</a:t>
+              <a:t>Setup Time: &lt; 3 minutes from rugged backpack unboxing to flight.</a:t>
             </a:r>
           </a:p>
           <a:p>
-            <a:pPr algn="l" marL="312182" indent="-156091" lvl="1">
-              <a:lnSpc>
-                <a:spcPts val="2070"/>
-              </a:lnSpc>
-              <a:buFont typeface="Arial"/>
-              <a:buChar char="•"/>
-            </a:pPr>
             <a:r>
-              <a:rPr lang="en-US" b="true" sz="1725">
-                <a:solidFill>
-                  <a:srgbClr val="1F497D"/>
-                </a:solidFill>
-                <a:latin typeface="Calibri (MS) Bold"/>
-                <a:ea typeface="Calibri (MS) Bold"/>
-                <a:cs typeface="Calibri (MS) Bold"/>
-                <a:sym typeface="Calibri (MS) Bold"/>
-              </a:rPr>
-              <a:t>Quick-Swap Battery: </a:t>
-            </a:r>
-            <a:r>
-              <a:rPr lang="en-US" sz="1725">
+              <a:rPr sz="1550">
                 <a:solidFill>
                   <a:srgbClr val="1E2638"/>
                 </a:solidFill>
-                <a:latin typeface="Calibri (MS)"/>
-                <a:ea typeface="Calibri (MS)"/>
-                <a:cs typeface="Calibri (MS)"/>
-                <a:sym typeface="Calibri (MS)"/>
+                <a:latin typeface="Calibri"/>
               </a:rPr>
-              <a:t>Dual 4S LiPo tray for continuous sortie coverage.</a:t>
+              <a:t>Quick-Swap Battery: Dual 4S LiPo tray for continuous sortie coverage.</a:t>
+            </a:r>
+          </a:p>
+          <a:p>
+            <a:r>
+              <a:rPr sz="1550">
+                <a:solidFill>
+                  <a:srgbClr val="1E2638"/>
+                </a:solidFill>
+                <a:latin typeface="Calibri"/>
+              </a:rPr>
+              <a:t>Zero Ground Compute Burden: 100% onboard processing enables deployment via low-power tablets or handheld LoRa pagers.</a:t>
             </a:r>
           </a:p>
         </p:txBody>

</xml_diff>